<commit_message>
docs: show max global batch across input lengths
Add a fifth slide for 4K to 1M. Spill from HBM enters the GPU through H2D at 51.2 GB/s, including remote DDR.

Co-authored-by: 69515164-rgb <69515164-rgb@users.noreply.github.com>
</commit_message>
<xml_diff>
--- a/docs/deepseek-10t-slo.pptx
+++ b/docs/deepseek-10t-slo.pptx
@@ -9,6 +9,7 @@
     <p:sldId id="257" r:id="rId9"/>
     <p:sldId id="258" r:id="rId10"/>
     <p:sldId id="259" r:id="rId11"/>
+    <p:sldId id="260" r:id="rId12"/>
   </p:sldIdLst>
   <p:sldSz cx="12191695" cy="6858000" type="screen4x3"/>
   <p:notesSz cx="6858000" cy="9144000"/>
@@ -505,7 +506,7 @@
           <a:lstStyle/>
           <a:p>
             <a:r>
-              <a:t>1.6T 来自 V4-Pro 论文 arXiv:2606.19348：61 层，隐藏 7168，384 个路由专家，中间维 3072，每 token 激活 6 个，激活参数 49B。单个路由专家在全部层上是 3×7168×3072×61 = 4.030×10^9。384 个专家为 1.547×10^12，总参数 1.600×10^12 减去这一项，其余 5.260×10^10 含共享专家、注意力、mHC、词表和 MTP。10T 把专家数解成 2469，总参数 = 2469×4.030×10^9 + 5.260×10^10 = 1.000×10^13。FP4 容量 = 2469×4.030×10^9×0.5 字节 = 4.975 TB。640 GB 卡下限是 ceil(4.975 TB / 640 GB) = 8。单 token 通信量 6×3×7168×61 = 7.87×10^6 字节，专家总数变了，每 token 仍只派 6 个，所以通信量不变。后面三页不用 640 GB 这套卡，改用 96 GB、128 卡超节点。</a:t>
+              <a:t>1.6T 来自 V4-Pro 论文 arXiv:2606.19348：61 层，隐藏 7168，384 个路由专家，中间维 3072，每 token 激活 6 个，激活参数 49B。单个路由专家在全部层上是 3×7168×3072×61 = 4.030×10^9。384 个专家为 1.547×10^12，总参数 1.600×10^12 减去这一项，其余 5.260×10^10 含共享专家、注意力、mHC、词表和 MTP。10T 把专家数解成 2469，总参数 = 2469×4.030×10^9 + 5.260×10^10 = 1.000×10^13。FP4 容量 = 2469×4.030×10^9×0.5 字节 = 4.975 TB。640 GB 卡下限是 ceil(4.975 TB / 640 GB) = 8。单 token 通信量 6×3×7168×61 = 7.87×10^6 字节，专家总数变了，每 token 仍只派 6 个，所以通信量不变。后面几页不用 640 GB 这套卡，改用 96 GB、128 卡超节点。批大小都是 128 卡这一份副本的全局批。</a:t>
             </a:r>
           </a:p>
         </p:txBody>
@@ -645,7 +646,7 @@
           <a:lstStyle/>
           <a:p>
             <a:r>
-              <a:t>Decode 与 Prefill 用同一份 128 卡副本：注意力 TP=8、DP=16，MoE EP=128。加 Decode 节点是多副本，单副本的 TPOT 不变。一步 = 注意力侧最长的一笔 + 专家侧最长的一笔。注意力侧在计算、读 KV、机内 allreduce 里取最大。专家侧在计算、读权重、EP combine 里取最大。命中率 = 1 − exp(−6×BS / 2469)。BS=231 时为 43%。最忙卡专家数 = 均值 + 2 个标准差，约 12.6，封顶 19.3。读权重 (12.6×2.015 GB + 4.03 GB) / 3.2 TB/s = 9.2 ms。全部路由专家加共享专家是 13.4 ms，超过 10 ms，所以不能把专家表一次扫完。专家计算受 Cube 对齐拖累：1.3 token 按 16 行砖，效率 8%，时间 2.6 ms，仍短于读权重。机内 allreduce：ceil(231/16)=15 条，每条 7168×2 字节，环上每层 2×7/8，61 层除以 40 GB/s = 0.57 ms。输入加长后，注意力计算和 KV 读取变多，读权重能占用的额度变少，批从 231 降到 179。在最大输入上，读权重 8.2 ms，注意力计算 1.8 ms，相加仍约 10 ms。从主机换入一个专家：2.015 GB / (64 GB/s×80%) ≈ 39 ms，放不进 10 ms 这一步。</a:t>
+              <a:t>Decode 与 Prefill 用同一份 128 卡副本：注意力 TP=8、DP=16，MoE EP=128。加 Decode 节点是多副本，单副本的 TPOT 不变。一步 = 注意力侧最长的一笔 + 专家侧最长的一笔。注意力侧在计算、读 KV、机内 allreduce 里取最大。专家侧在计算、读权重、EP combine 里取最大。命中率 = 1 − exp(−6×BS / 2469)。BS=231 时为 43%。最忙卡专家数 = 均值 + 2 个标准差，约 12.6，封顶 19.3。读权重 (12.6×2.015 GB + 4.03 GB) / 3.2 TB/s = 9.2 ms。全部路由专家加共享专家是 13.4 ms，超过 10 ms，所以不能把专家表一次扫完。专家计算受 Cube 对齐拖累：1.3 token 按 16 行砖，效率 8%，时间 2.6 ms，仍短于读权重。机内 allreduce：ceil(231/16)=15 条，每条 7168×2 字节，环上每层 2×7/8，61 层除以 40 GB/s = 0.57 ms。输入加长后，读权重能占用的额度变少。全局批从 4K 的 231 降到 1M 的 213，KV 仍放得进 HBM。对照表在第 5 页。从主机换入一个专家：2.015 GB / (64 GB/s×80%) ≈ 39 ms，放不进 10 ms 这一步。</a:t>
             </a:r>
           </a:p>
         </p:txBody>
@@ -715,7 +716,77 @@
           <a:lstStyle/>
           <a:p>
             <a:r>
-              <a:t>30 毫秒用的切分与 10 毫秒相同：TP=8，DP=16，EP=128，128 卡一份副本。BS=6928 时 6×6928/2469 ≈ 16.8，命中率 1−exp(−16.8) 已经是 1，每卡 19.3 个专家全醒。读权重因此停在整表扫描：(38.9 GB + 4.03 GB) / 3.2 TB/s = 13.4 ms。机内 allreduce：ceil(6928/16)=433 条，payload=433×7168×2，环上每层 2×7/8，乘 61 层，除以 40 GB/s = 16.6 ms。两项相加 30.0 ms。专家 combine 只有 0.9 ms，所以 30 毫秒的通信限制在机内 8 卡，不在 128 卡专家域。专家计算 11.9 ms：每专家约 17 个 token，ceil(17/16)×16=32，效率 17/32=53%。显存：每卡 96 − 38.9 − 4.03 − 2.42 − 6 = 44.7 GB，128 卡共 5.72 TB。每条 KV = S×4939.5 B + 4.50 MB。1×10^6 时约 4.94 GB，能放 1156 条，这一步 18.2 ms，30 ms 还没用完。2.08×10^6 时约 10.3 GB，能放 555 条，这一步 18.1 ms。1×10^6 的 30 毫秒搜索结果被显存上限截断，批等于 1156，时间 18.2 ms。</a:t>
+              <a:t>30 毫秒用的切分与 10 毫秒相同：TP=8，DP=16，EP=128，128 卡一份副本。BS=6928 时 6×6928/2469 ≈ 16.8，命中率 1−exp(−16.8) 已经是 1，每卡 19.3 个专家全醒。读权重因此停在整表扫描：(38.9 GB + 4.03 GB) / 3.2 TB/s = 13.4 ms。机内 allreduce：ceil(6928/16)=433 条，payload=433×7168×2，环上每层 2×7/8，乘 61 层，除以 40 GB/s = 16.6 ms。两项相加 30.0 ms。专家 combine 只有 0.9 ms，所以 30 毫秒的通信限制在机内 8 卡，不在 128 卡专家域。专家计算 11.9 ms：每专家约 17 个 token，ceil(17/16)×16=32，效率 17/32=53%。显存：每卡 96 − 38.9 − 4.03 − 2.42 − 6 = 44.7 GB，128 卡共 5.72 TB。HBM 放不下的 KV 走本卡 H2D，64×0.8 = 51.2 GB/s。远端 DDR 进卡也走这条 H2D，不按 DDR 的 1288.8 GB/s 计。1M 时 HBM 能放 1103 条，H2D 再多放一些，30 毫秒全局批到 1265，其中约 13% 的存量经 H2D 读。下一页是 4K 到 1M 的全局批对照。</a:t>
+            </a:r>
+          </a:p>
+        </p:txBody>
+      </p:sp>
+      <p:sp>
+        <p:nvSpPr>
+          <p:cNvPr id="4" name="Slide Number Placeholder 3"/>
+          <p:cNvSpPr>
+            <a:spLocks noGrp="1"/>
+          </p:cNvSpPr>
+          <p:nvPr>
+            <p:ph type="sldNum" idx="5" sz="quarter"/>
+          </p:nvPr>
+        </p:nvSpPr>
+        <p:spPr/>
+      </p:sp>
+    </p:spTree>
+  </p:cSld>
+  <p:clrMapOvr>
+    <a:masterClrMapping/>
+  </p:clrMapOvr>
+</p:notes>
+</file>
+
+<file path=ppt/notesSlides/notesSlide5.xml><?xml version="1.0" encoding="utf-8"?>
+<p:notes xmlns:a="http://schemas.openxmlformats.org/drawingml/2006/main" xmlns:p="http://schemas.openxmlformats.org/presentationml/2006/main" xmlns:r="http://schemas.openxmlformats.org/officeDocument/2006/relationships">
+  <p:cSld>
+    <p:spTree>
+      <p:nvGrpSpPr>
+        <p:cNvPr id="1" name=""/>
+        <p:cNvGrpSpPr/>
+        <p:nvPr/>
+      </p:nvGrpSpPr>
+      <p:grpSpPr>
+        <a:xfrm>
+          <a:off x="0" y="0"/>
+          <a:ext cx="0" cy="0"/>
+          <a:chOff x="0" y="0"/>
+          <a:chExt cx="0" cy="0"/>
+        </a:xfrm>
+      </p:grpSpPr>
+      <p:sp>
+        <p:nvSpPr>
+          <p:cNvPr id="2" name="Slide Image Placeholder 1"/>
+          <p:cNvSpPr>
+            <a:spLocks noGrp="1"/>
+          </p:cNvSpPr>
+          <p:nvPr>
+            <p:ph type="sldImg" idx="2"/>
+          </p:nvPr>
+        </p:nvSpPr>
+        <p:spPr/>
+      </p:sp>
+      <p:sp>
+        <p:nvSpPr>
+          <p:cNvPr id="3" name="Notes Placeholder 2"/>
+          <p:cNvSpPr>
+            <a:spLocks noGrp="1"/>
+          </p:cNvSpPr>
+          <p:nvPr>
+            <p:ph type="body" idx="3" sz="quarter"/>
+          </p:nvPr>
+        </p:nvSpPr>
+        <p:spPr/>
+        <p:txBody>
+          <a:bodyPr/>
+          <a:lstStyle/>
+          <a:p>
+            <a:r>
+              <a:t>BS 一律是 128 卡副本的全局批。每卡条数 = 全局批 / 128。存量 = S×4939.5 字节 + 4.50 MB。一步真正读的是压缩 indexer、最多 1024 条完整 KV 和 HCA，1M 时约为存量的 13%。HBM 余量 5.72 TB。溢出进 GPU 的口是本卡 H2D：64×0.8 = 51.2 GB/s。节点 DDR 有效 1031 GB/s，8 条 H2D 合计 410 GB/s，所以卡点在 H2D，不能把 1031/8 = 128.9 GB/s 当成 GPU 的读取速度。远端 DDR 进这张卡仍走这张卡的 H2D，和本机 DDR 共用 51.2 GB/s。三条通路同时走，取最慢的一条，再和专家阶段相加。10 毫秒全局批：4K 231，8K 231，32K 231，128K 229，256K 226，512K 222，1M 213。30 毫秒全局批：4K 到 128K 为 6928，256K 为 4991，512K 为 2518，1M 为 1265。Prefill 90% 命中时，现算约为冷启动的 10%，1M 的 TTFT 为 0.345 秒，参数面读 KV 0.91 毫秒。</a:t>
             </a:r>
           </a:p>
         </p:txBody>
@@ -3885,7 +3956,7 @@
                 <a:ea typeface="Microsoft YaHei"/>
                 <a:cs typeface="Microsoft YaHei"/>
               </a:rPr>
-              <a:t>1  /  4</a:t>
+              <a:t>1  /  5</a:t>
             </a:r>
           </a:p>
         </p:txBody>
@@ -6575,7 +6646,7 @@
                 <a:ea typeface="Microsoft YaHei"/>
                 <a:cs typeface="Microsoft YaHei"/>
               </a:rPr>
-              <a:t>2  /  4</a:t>
+              <a:t>2  /  5</a:t>
             </a:r>
           </a:p>
         </p:txBody>
@@ -9429,7 +9500,7 @@
                 <a:ea typeface="Microsoft YaHei"/>
                 <a:cs typeface="Microsoft YaHei"/>
               </a:rPr>
-              <a:t>3  /  4</a:t>
+              <a:t>3  /  5</a:t>
             </a:r>
           </a:p>
         </p:txBody>
@@ -12409,7 +12480,7 @@
                 <a:ea typeface="Microsoft YaHei"/>
                 <a:cs typeface="Microsoft YaHei"/>
               </a:rPr>
-              <a:t>仍是读权重</a:t>
+              <a:t>每卡 1.8 条</a:t>
             </a:r>
           </a:p>
         </p:txBody>
@@ -12496,7 +12567,7 @@
                 <a:ea typeface="Microsoft YaHei"/>
                 <a:cs typeface="Microsoft YaHei"/>
               </a:rPr>
-              <a:t>1×10^6</a:t>
+              <a:t>256K</a:t>
             </a:r>
           </a:p>
         </p:txBody>
@@ -12538,7 +12609,7 @@
                 <a:ea typeface="Microsoft YaHei"/>
                 <a:cs typeface="Microsoft YaHei"/>
               </a:rPr>
-              <a:t>214</a:t>
+              <a:t>226</a:t>
             </a:r>
           </a:p>
         </p:txBody>
@@ -12601,7 +12672,7 @@
                 <a:ea typeface="Microsoft YaHei"/>
                 <a:cs typeface="Microsoft YaHei"/>
               </a:rPr>
-              <a:t>KV 开始占额度</a:t>
+              <a:t>每卡 1.8 条</a:t>
             </a:r>
           </a:p>
         </p:txBody>
@@ -12688,7 +12759,7 @@
                 <a:ea typeface="Microsoft YaHei"/>
                 <a:cs typeface="Microsoft YaHei"/>
               </a:rPr>
-              <a:t>2.08×10^6</a:t>
+              <a:t>1M</a:t>
             </a:r>
           </a:p>
         </p:txBody>
@@ -12730,7 +12801,7 @@
                 <a:ea typeface="Microsoft YaHei"/>
                 <a:cs typeface="Microsoft YaHei"/>
               </a:rPr>
-              <a:t>179</a:t>
+              <a:t>213</a:t>
             </a:r>
           </a:p>
         </p:txBody>
@@ -12772,7 +12843,7 @@
                 <a:ea typeface="Microsoft YaHei"/>
                 <a:cs typeface="Microsoft YaHei"/>
               </a:rPr>
-              <a:t>读权重 8.2 毫秒</a:t>
+              <a:t>全局批</a:t>
             </a:r>
           </a:p>
           <a:p>
@@ -12793,7 +12864,7 @@
                 <a:ea typeface="Microsoft YaHei"/>
                 <a:cs typeface="Microsoft YaHei"/>
               </a:rPr>
-              <a:t>注意力计算 1.8 毫秒</a:t>
+              <a:t>每卡 1.7 条</a:t>
             </a:r>
           </a:p>
         </p:txBody>
@@ -12980,7 +13051,7 @@
                 <a:ea typeface="Microsoft YaHei"/>
                 <a:cs typeface="Microsoft YaHei"/>
               </a:rPr>
-              <a:t>4  /  4</a:t>
+              <a:t>4  /  5</a:t>
             </a:r>
           </a:p>
         </p:txBody>
@@ -13938,7 +14009,7 @@
                           <a:ea typeface="Microsoft YaHei"/>
                           <a:cs typeface="Microsoft YaHei"/>
                         </a:rPr>
-                        <a:t>KV 在短输入上可忽略</a:t>
+                        <a:t>短输入全在 HBM</a:t>
                       </a:r>
                     </a:p>
                     <a:p>
@@ -13962,7 +14033,7 @@
                           <a:ea typeface="Microsoft YaHei"/>
                           <a:cs typeface="Microsoft YaHei"/>
                         </a:rPr>
-                        <a:t>长输入改由容量卡住</a:t>
+                        <a:t>放不下走本卡 H2D 51.2 GB/s</a:t>
                       </a:r>
                     </a:p>
                   </a:txBody>
@@ -15723,7 +15794,7 @@
                 <a:ea typeface="Microsoft YaHei"/>
                 <a:cs typeface="Microsoft YaHei"/>
               </a:rPr>
-              <a:t>每卡 54 条</a:t>
+              <a:t>全局批，每卡 54 条</a:t>
             </a:r>
           </a:p>
           <a:p>
@@ -15744,7 +15815,7 @@
                 <a:ea typeface="Microsoft YaHei"/>
                 <a:cs typeface="Microsoft YaHei"/>
               </a:rPr>
-              <a:t>一步顶满 30 毫秒</a:t>
+              <a:t>全在 HBM</a:t>
             </a:r>
           </a:p>
         </p:txBody>
@@ -15831,7 +15902,7 @@
                 <a:ea typeface="Microsoft YaHei"/>
                 <a:cs typeface="Microsoft YaHei"/>
               </a:rPr>
-              <a:t>1×10^6</a:t>
+              <a:t>256K</a:t>
             </a:r>
           </a:p>
         </p:txBody>
@@ -15873,7 +15944,7 @@
                 <a:ea typeface="Microsoft YaHei"/>
                 <a:cs typeface="Microsoft YaHei"/>
               </a:rPr>
-              <a:t>1156</a:t>
+              <a:t>4991</a:t>
             </a:r>
           </a:p>
         </p:txBody>
@@ -15915,7 +15986,7 @@
                 <a:ea typeface="Microsoft YaHei"/>
                 <a:cs typeface="Microsoft YaHei"/>
               </a:rPr>
-              <a:t>每条 4.94 GB</a:t>
+              <a:t>全局批，每卡 39 条</a:t>
             </a:r>
           </a:p>
           <a:p>
@@ -15936,7 +16007,7 @@
                 <a:ea typeface="Microsoft YaHei"/>
                 <a:cs typeface="Microsoft YaHei"/>
               </a:rPr>
-              <a:t>这一步 18.2 毫秒</a:t>
+              <a:t>12% 经 H2D 读</a:t>
             </a:r>
           </a:p>
         </p:txBody>
@@ -16023,7 +16094,7 @@
                 <a:ea typeface="Microsoft YaHei"/>
                 <a:cs typeface="Microsoft YaHei"/>
               </a:rPr>
-              <a:t>2.08×10^6</a:t>
+              <a:t>512K</a:t>
             </a:r>
           </a:p>
         </p:txBody>
@@ -16065,7 +16136,7 @@
                 <a:ea typeface="Microsoft YaHei"/>
                 <a:cs typeface="Microsoft YaHei"/>
               </a:rPr>
-              <a:t>555</a:t>
+              <a:t>2518</a:t>
             </a:r>
           </a:p>
         </p:txBody>
@@ -16107,7 +16178,7 @@
                 <a:ea typeface="Microsoft YaHei"/>
                 <a:cs typeface="Microsoft YaHei"/>
               </a:rPr>
-              <a:t>每条 10.3 GB</a:t>
+              <a:t>全局批，每卡 20 条</a:t>
             </a:r>
           </a:p>
           <a:p>
@@ -16128,7 +16199,7 @@
                 <a:ea typeface="Microsoft YaHei"/>
                 <a:cs typeface="Microsoft YaHei"/>
               </a:rPr>
-              <a:t>这一步 18.1 毫秒</a:t>
+              <a:t>约 12% 经 H2D 读</a:t>
             </a:r>
           </a:p>
         </p:txBody>
@@ -16215,7 +16286,7 @@
                 <a:ea typeface="Microsoft YaHei"/>
                 <a:cs typeface="Microsoft YaHei"/>
               </a:rPr>
-              <a:t>KV 余量</a:t>
+              <a:t>1M</a:t>
             </a:r>
           </a:p>
         </p:txBody>
@@ -16257,7 +16328,7 @@
                 <a:ea typeface="Microsoft YaHei"/>
                 <a:cs typeface="Microsoft YaHei"/>
               </a:rPr>
-              <a:t>5.72 TB</a:t>
+              <a:t>1265</a:t>
             </a:r>
           </a:p>
         </p:txBody>
@@ -16299,7 +16370,7 @@
                 <a:ea typeface="Microsoft YaHei"/>
                 <a:cs typeface="Microsoft YaHei"/>
               </a:rPr>
-              <a:t>96−38.9−4.03−2.42−6</a:t>
+              <a:t>全局批，每卡 9.9 条</a:t>
             </a:r>
           </a:p>
           <a:p>
@@ -16320,7 +16391,4057 @@
                 <a:ea typeface="Microsoft YaHei"/>
                 <a:cs typeface="Microsoft YaHei"/>
               </a:rPr>
-              <a:t>每卡 44.7 GB</a:t>
+              <a:t>13% 经 H2D 读</a:t>
+            </a:r>
+          </a:p>
+        </p:txBody>
+      </p:sp>
+    </p:spTree>
+  </p:cSld>
+  <p:clrMapOvr>
+    <a:masterClrMapping/>
+  </p:clrMapOvr>
+</p:sld>
+</file>
+
+<file path=ppt/slides/slide5.xml><?xml version="1.0" encoding="utf-8"?>
+<p:sld xmlns:a="http://schemas.openxmlformats.org/drawingml/2006/main" xmlns:p="http://schemas.openxmlformats.org/presentationml/2006/main" xmlns:r="http://schemas.openxmlformats.org/officeDocument/2006/relationships">
+  <p:cSld>
+    <p:spTree>
+      <p:nvGrpSpPr>
+        <p:cNvPr id="1" name=""/>
+        <p:cNvGrpSpPr/>
+        <p:nvPr/>
+      </p:nvGrpSpPr>
+      <p:grpSpPr/>
+      <p:sp>
+        <p:nvSpPr>
+          <p:cNvPr id="2" name="Rectangle 1"/>
+          <p:cNvSpPr/>
+          <p:nvPr/>
+        </p:nvSpPr>
+        <p:spPr>
+          <a:xfrm>
+            <a:off x="0" y="0"/>
+            <a:ext cx="12191695" cy="73152"/>
+          </a:xfrm>
+          <a:prstGeom prst="rect">
+            <a:avLst/>
+          </a:prstGeom>
+          <a:solidFill>
+            <a:srgbClr val="145A96"/>
+          </a:solidFill>
+          <a:ln>
+            <a:noFill/>
+          </a:ln>
+        </p:spPr>
+        <p:style>
+          <a:lnRef idx="1">
+            <a:schemeClr val="accent1"/>
+          </a:lnRef>
+          <a:fillRef idx="3">
+            <a:schemeClr val="accent1"/>
+          </a:fillRef>
+          <a:effectRef idx="2">
+            <a:schemeClr val="accent1"/>
+          </a:effectRef>
+          <a:fontRef idx="minor">
+            <a:schemeClr val="lt1"/>
+          </a:fontRef>
+        </p:style>
+        <p:txBody>
+          <a:bodyPr rtlCol="0" anchor="ctr"/>
+          <a:lstStyle/>
+          <a:p>
+            <a:pPr algn="ctr"/>
+          </a:p>
+        </p:txBody>
+      </p:sp>
+      <p:sp>
+        <p:nvSpPr>
+          <p:cNvPr id="3" name="TextBox 2"/>
+          <p:cNvSpPr txBox="1"/>
+          <p:nvPr/>
+        </p:nvSpPr>
+        <p:spPr>
+          <a:xfrm>
+            <a:off x="384048" y="146304"/>
+            <a:ext cx="9692640" cy="256032"/>
+          </a:xfrm>
+          <a:prstGeom prst="rect">
+            <a:avLst/>
+          </a:prstGeom>
+          <a:noFill/>
+        </p:spPr>
+        <p:txBody>
+          <a:bodyPr wrap="square" lIns="0" rIns="0" tIns="0" bIns="0" anchor="ctr"/>
+          <a:lstStyle/>
+          <a:p>
+            <a:pPr algn="l">
+              <a:spcBef>
+                <a:spcPts val="0"/>
+              </a:spcBef>
+              <a:spcAft>
+                <a:spcPts val="0"/>
+              </a:spcAft>
+            </a:pPr>
+            <a:r>
+              <a:rPr sz="1200" b="1">
+                <a:solidFill>
+                  <a:srgbClr val="145A96"/>
+                </a:solidFill>
+                <a:latin typeface="Microsoft YaHei"/>
+                <a:ea typeface="Microsoft YaHei"/>
+                <a:cs typeface="Microsoft YaHei"/>
+              </a:rPr>
+              <a:t>Decode    ·    不同输入下的最大全局批</a:t>
+            </a:r>
+          </a:p>
+        </p:txBody>
+      </p:sp>
+      <p:sp>
+        <p:nvSpPr>
+          <p:cNvPr id="4" name="TextBox 3"/>
+          <p:cNvSpPr txBox="1"/>
+          <p:nvPr/>
+        </p:nvSpPr>
+        <p:spPr>
+          <a:xfrm>
+            <a:off x="384048" y="384048"/>
+            <a:ext cx="11430000" cy="384048"/>
+          </a:xfrm>
+          <a:prstGeom prst="rect">
+            <a:avLst/>
+          </a:prstGeom>
+          <a:noFill/>
+        </p:spPr>
+        <p:txBody>
+          <a:bodyPr wrap="square" lIns="0" rIns="0" tIns="0" bIns="0" anchor="ctr"/>
+          <a:lstStyle/>
+          <a:p>
+            <a:pPr algn="l">
+              <a:spcBef>
+                <a:spcPts val="0"/>
+              </a:spcBef>
+              <a:spcAft>
+                <a:spcPts val="0"/>
+              </a:spcAft>
+            </a:pPr>
+            <a:r>
+              <a:rPr sz="2600" b="1">
+                <a:solidFill>
+                  <a:srgbClr val="0E2A47"/>
+                </a:solidFill>
+                <a:latin typeface="Microsoft YaHei"/>
+                <a:ea typeface="Microsoft YaHei"/>
+                <a:cs typeface="Microsoft YaHei"/>
+              </a:rPr>
+              <a:t>输入越长，30 毫秒的全局批掉得越快</a:t>
+            </a:r>
+          </a:p>
+        </p:txBody>
+      </p:sp>
+      <p:sp>
+        <p:nvSpPr>
+          <p:cNvPr id="5" name="TextBox 4"/>
+          <p:cNvSpPr txBox="1"/>
+          <p:nvPr/>
+        </p:nvSpPr>
+        <p:spPr>
+          <a:xfrm>
+            <a:off x="10424160" y="164592"/>
+            <a:ext cx="1371600" cy="237744"/>
+          </a:xfrm>
+          <a:prstGeom prst="rect">
+            <a:avLst/>
+          </a:prstGeom>
+          <a:noFill/>
+        </p:spPr>
+        <p:txBody>
+          <a:bodyPr wrap="square" lIns="0" rIns="0" tIns="0" bIns="0" anchor="ctr"/>
+          <a:lstStyle/>
+          <a:p>
+            <a:pPr algn="r">
+              <a:spcBef>
+                <a:spcPts val="0"/>
+              </a:spcBef>
+              <a:spcAft>
+                <a:spcPts val="0"/>
+              </a:spcAft>
+            </a:pPr>
+            <a:r>
+              <a:rPr sz="1200" b="0">
+                <a:solidFill>
+                  <a:srgbClr val="5A636E"/>
+                </a:solidFill>
+                <a:latin typeface="Microsoft YaHei"/>
+                <a:ea typeface="Microsoft YaHei"/>
+                <a:cs typeface="Microsoft YaHei"/>
+              </a:rPr>
+              <a:t>5  /  5</a:t>
+            </a:r>
+          </a:p>
+        </p:txBody>
+      </p:sp>
+      <p:sp>
+        <p:nvSpPr>
+          <p:cNvPr id="6" name="Rectangle 5"/>
+          <p:cNvSpPr/>
+          <p:nvPr/>
+        </p:nvSpPr>
+        <p:spPr>
+          <a:xfrm>
+            <a:off x="384048" y="6565392"/>
+            <a:ext cx="11430000" cy="9144"/>
+          </a:xfrm>
+          <a:prstGeom prst="rect">
+            <a:avLst/>
+          </a:prstGeom>
+          <a:solidFill>
+            <a:srgbClr val="D6DCE2"/>
+          </a:solidFill>
+          <a:ln>
+            <a:noFill/>
+          </a:ln>
+        </p:spPr>
+        <p:style>
+          <a:lnRef idx="1">
+            <a:schemeClr val="accent1"/>
+          </a:lnRef>
+          <a:fillRef idx="3">
+            <a:schemeClr val="accent1"/>
+          </a:fillRef>
+          <a:effectRef idx="2">
+            <a:schemeClr val="accent1"/>
+          </a:effectRef>
+          <a:fontRef idx="minor">
+            <a:schemeClr val="lt1"/>
+          </a:fontRef>
+        </p:style>
+        <p:txBody>
+          <a:bodyPr rtlCol="0" anchor="ctr"/>
+          <a:lstStyle/>
+          <a:p>
+            <a:pPr algn="ctr"/>
+          </a:p>
+        </p:txBody>
+      </p:sp>
+      <p:sp>
+        <p:nvSpPr>
+          <p:cNvPr id="7" name="TextBox 6"/>
+          <p:cNvSpPr txBox="1"/>
+          <p:nvPr/>
+        </p:nvSpPr>
+        <p:spPr>
+          <a:xfrm>
+            <a:off x="384048" y="6583680"/>
+            <a:ext cx="11430000" cy="219456"/>
+          </a:xfrm>
+          <a:prstGeom prst="rect">
+            <a:avLst/>
+          </a:prstGeom>
+          <a:noFill/>
+        </p:spPr>
+        <p:txBody>
+          <a:bodyPr wrap="square" lIns="0" rIns="0" tIns="0" bIns="0" anchor="ctr"/>
+          <a:lstStyle/>
+          <a:p>
+            <a:pPr algn="l">
+              <a:spcBef>
+                <a:spcPts val="0"/>
+              </a:spcBef>
+              <a:spcAft>
+                <a:spcPts val="0"/>
+              </a:spcAft>
+            </a:pPr>
+            <a:r>
+              <a:rPr sz="1100" b="0">
+                <a:solidFill>
+                  <a:srgbClr val="5A636E"/>
+                </a:solidFill>
+                <a:latin typeface="Microsoft YaHei"/>
+                <a:ea typeface="Microsoft YaHei"/>
+                <a:cs typeface="Microsoft YaHei"/>
+              </a:rPr>
+              <a:t>10T 为外推    ·    单请求一份 128 卡副本    ·    访存与通信取峰值的 80%    ·    计算按 Cube 16 行对齐</a:t>
+            </a:r>
+          </a:p>
+        </p:txBody>
+      </p:sp>
+      <p:sp>
+        <p:nvSpPr>
+          <p:cNvPr id="8" name="Rounded Rectangle 7"/>
+          <p:cNvSpPr/>
+          <p:nvPr/>
+        </p:nvSpPr>
+        <p:spPr>
+          <a:xfrm>
+            <a:off x="384048" y="841248"/>
+            <a:ext cx="11430000" cy="438912"/>
+          </a:xfrm>
+          <a:prstGeom prst="roundRect">
+            <a:avLst/>
+          </a:prstGeom>
+          <a:solidFill>
+            <a:srgbClr val="E7F3F2"/>
+          </a:solidFill>
+          <a:ln>
+            <a:noFill/>
+          </a:ln>
+        </p:spPr>
+        <p:style>
+          <a:lnRef idx="1">
+            <a:schemeClr val="accent1"/>
+          </a:lnRef>
+          <a:fillRef idx="3">
+            <a:schemeClr val="accent1"/>
+          </a:fillRef>
+          <a:effectRef idx="2">
+            <a:schemeClr val="accent1"/>
+          </a:effectRef>
+          <a:fontRef idx="minor">
+            <a:schemeClr val="lt1"/>
+          </a:fontRef>
+        </p:style>
+        <p:txBody>
+          <a:bodyPr rtlCol="0" anchor="ctr"/>
+          <a:lstStyle/>
+          <a:p>
+            <a:pPr algn="ctr"/>
+          </a:p>
+        </p:txBody>
+      </p:sp>
+      <p:sp>
+        <p:nvSpPr>
+          <p:cNvPr id="9" name="TextBox 8"/>
+          <p:cNvSpPr txBox="1"/>
+          <p:nvPr/>
+        </p:nvSpPr>
+        <p:spPr>
+          <a:xfrm>
+            <a:off x="530352" y="841248"/>
+            <a:ext cx="11137392" cy="438912"/>
+          </a:xfrm>
+          <a:prstGeom prst="rect">
+            <a:avLst/>
+          </a:prstGeom>
+          <a:noFill/>
+        </p:spPr>
+        <p:txBody>
+          <a:bodyPr wrap="square" lIns="0" rIns="0" tIns="0" bIns="0" anchor="ctr"/>
+          <a:lstStyle/>
+          <a:p>
+            <a:pPr algn="l">
+              <a:spcBef>
+                <a:spcPts val="0"/>
+              </a:spcBef>
+              <a:spcAft>
+                <a:spcPts val="0"/>
+              </a:spcAft>
+            </a:pPr>
+            <a:r>
+              <a:rPr sz="1400" b="1">
+                <a:solidFill>
+                  <a:srgbClr val="0E7A76"/>
+                </a:solidFill>
+                <a:latin typeface="Microsoft YaHei"/>
+                <a:ea typeface="Microsoft YaHei"/>
+                <a:cs typeface="Microsoft YaHei"/>
+              </a:rPr>
+              <a:t>全局批是 128 卡一份副本上的条数，每卡 = 全局批 / 128。HBM 放不下的 KV 走本卡 H2D，每卡 51.2 GB/s。远端 DDR 进卡也走这条 H2D。</a:t>
+            </a:r>
+          </a:p>
+        </p:txBody>
+      </p:sp>
+      <p:graphicFrame>
+        <p:nvGraphicFramePr>
+          <p:cNvPr id="10" name="Table 9"/>
+          <p:cNvGraphicFramePr>
+            <a:graphicFrameLocks noGrp="1"/>
+          </p:cNvGraphicFramePr>
+          <p:nvPr/>
+        </p:nvGraphicFramePr>
+        <p:xfrm>
+          <a:off x="384048" y="1426464"/>
+          <a:ext cx="11430000" cy="3694176"/>
+        </p:xfrm>
+        <a:graphic>
+          <a:graphicData uri="http://schemas.openxmlformats.org/drawingml/2006/table">
+            <a:tbl>
+              <a:tblPr firstRow="1"/>
+              <a:tblGrid>
+                <a:gridCol w="1051560"/>
+                <a:gridCol w="1325880"/>
+                <a:gridCol w="1325880"/>
+                <a:gridCol w="1554480"/>
+                <a:gridCol w="960120"/>
+                <a:gridCol w="1600200"/>
+                <a:gridCol w="960120"/>
+                <a:gridCol w="2651760"/>
+              </a:tblGrid>
+              <a:tr h="365760">
+                <a:tc>
+                  <a:txBody>
+                    <a:bodyPr wrap="square"/>
+                    <a:lstStyle/>
+                    <a:p>
+                      <a:pPr algn="l">
+                        <a:spcBef>
+                          <a:spcPts val="0"/>
+                        </a:spcBef>
+                        <a:spcAft>
+                          <a:spcPts val="0"/>
+                        </a:spcAft>
+                        <a:lnSpc>
+                          <a:spcPct val="100000"/>
+                        </a:lnSpc>
+                      </a:pPr>
+                      <a:r>
+                        <a:rPr sz="1200" b="1">
+                          <a:solidFill>
+                            <a:srgbClr val="FFFFFF"/>
+                          </a:solidFill>
+                          <a:latin typeface="Microsoft YaHei"/>
+                          <a:ea typeface="Microsoft YaHei"/>
+                          <a:cs typeface="Microsoft YaHei"/>
+                        </a:rPr>
+                        <a:t>输入</a:t>
+                      </a:r>
+                    </a:p>
+                  </a:txBody>
+                  <a:tcPr marL="73152" marR="73152" marT="36576" marB="27432" anchor="ctr">
+                    <a:solidFill>
+                      <a:srgbClr val="0E2A47"/>
+                    </a:solidFill>
+                    <a:lnL w="6350">
+                      <a:solidFill>
+                        <a:srgbClr val="D6DCE2"/>
+                      </a:solidFill>
+                    </a:lnL>
+                    <a:lnR w="6350">
+                      <a:solidFill>
+                        <a:srgbClr val="D6DCE2"/>
+                      </a:solidFill>
+                    </a:lnR>
+                    <a:lnT w="6350">
+                      <a:solidFill>
+                        <a:srgbClr val="D6DCE2"/>
+                      </a:solidFill>
+                    </a:lnT>
+                    <a:lnB w="6350">
+                      <a:solidFill>
+                        <a:srgbClr val="D6DCE2"/>
+                      </a:solidFill>
+                    </a:lnB>
+                  </a:tcPr>
+                </a:tc>
+                <a:tc>
+                  <a:txBody>
+                    <a:bodyPr wrap="square"/>
+                    <a:lstStyle/>
+                    <a:p>
+                      <a:pPr algn="l">
+                        <a:spcBef>
+                          <a:spcPts val="0"/>
+                        </a:spcBef>
+                        <a:spcAft>
+                          <a:spcPts val="0"/>
+                        </a:spcAft>
+                        <a:lnSpc>
+                          <a:spcPct val="100000"/>
+                        </a:lnSpc>
+                      </a:pPr>
+                      <a:r>
+                        <a:rPr sz="1200" b="1">
+                          <a:solidFill>
+                            <a:srgbClr val="FFFFFF"/>
+                          </a:solidFill>
+                          <a:latin typeface="Microsoft YaHei"/>
+                          <a:ea typeface="Microsoft YaHei"/>
+                          <a:cs typeface="Microsoft YaHei"/>
+                        </a:rPr>
+                        <a:t>每条 KV</a:t>
+                      </a:r>
+                    </a:p>
+                  </a:txBody>
+                  <a:tcPr marL="73152" marR="73152" marT="36576" marB="27432" anchor="ctr">
+                    <a:solidFill>
+                      <a:srgbClr val="0E2A47"/>
+                    </a:solidFill>
+                    <a:lnL w="6350">
+                      <a:solidFill>
+                        <a:srgbClr val="D6DCE2"/>
+                      </a:solidFill>
+                    </a:lnL>
+                    <a:lnR w="6350">
+                      <a:solidFill>
+                        <a:srgbClr val="D6DCE2"/>
+                      </a:solidFill>
+                    </a:lnR>
+                    <a:lnT w="6350">
+                      <a:solidFill>
+                        <a:srgbClr val="D6DCE2"/>
+                      </a:solidFill>
+                    </a:lnT>
+                    <a:lnB w="6350">
+                      <a:solidFill>
+                        <a:srgbClr val="D6DCE2"/>
+                      </a:solidFill>
+                    </a:lnB>
+                  </a:tcPr>
+                </a:tc>
+                <a:tc>
+                  <a:txBody>
+                    <a:bodyPr wrap="square"/>
+                    <a:lstStyle/>
+                    <a:p>
+                      <a:pPr algn="l">
+                        <a:spcBef>
+                          <a:spcPts val="0"/>
+                        </a:spcBef>
+                        <a:spcAft>
+                          <a:spcPts val="0"/>
+                        </a:spcAft>
+                        <a:lnSpc>
+                          <a:spcPct val="100000"/>
+                        </a:lnSpc>
+                      </a:pPr>
+                      <a:r>
+                        <a:rPr sz="1200" b="1">
+                          <a:solidFill>
+                            <a:srgbClr val="FFFFFF"/>
+                          </a:solidFill>
+                          <a:latin typeface="Microsoft YaHei"/>
+                          <a:ea typeface="Microsoft YaHei"/>
+                          <a:cs typeface="Microsoft YaHei"/>
+                        </a:rPr>
+                        <a:t>HBM 能放</a:t>
+                      </a:r>
+                    </a:p>
+                  </a:txBody>
+                  <a:tcPr marL="73152" marR="73152" marT="36576" marB="27432" anchor="ctr">
+                    <a:solidFill>
+                      <a:srgbClr val="0E2A47"/>
+                    </a:solidFill>
+                    <a:lnL w="6350">
+                      <a:solidFill>
+                        <a:srgbClr val="D6DCE2"/>
+                      </a:solidFill>
+                    </a:lnL>
+                    <a:lnR w="6350">
+                      <a:solidFill>
+                        <a:srgbClr val="D6DCE2"/>
+                      </a:solidFill>
+                    </a:lnR>
+                    <a:lnT w="6350">
+                      <a:solidFill>
+                        <a:srgbClr val="D6DCE2"/>
+                      </a:solidFill>
+                    </a:lnT>
+                    <a:lnB w="6350">
+                      <a:solidFill>
+                        <a:srgbClr val="D6DCE2"/>
+                      </a:solidFill>
+                    </a:lnB>
+                  </a:tcPr>
+                </a:tc>
+                <a:tc>
+                  <a:txBody>
+                    <a:bodyPr wrap="square"/>
+                    <a:lstStyle/>
+                    <a:p>
+                      <a:pPr algn="l">
+                        <a:spcBef>
+                          <a:spcPts val="0"/>
+                        </a:spcBef>
+                        <a:spcAft>
+                          <a:spcPts val="0"/>
+                        </a:spcAft>
+                        <a:lnSpc>
+                          <a:spcPct val="100000"/>
+                        </a:lnSpc>
+                      </a:pPr>
+                      <a:r>
+                        <a:rPr sz="1200" b="1">
+                          <a:solidFill>
+                            <a:srgbClr val="FFFFFF"/>
+                          </a:solidFill>
+                          <a:latin typeface="Microsoft YaHei"/>
+                          <a:ea typeface="Microsoft YaHei"/>
+                          <a:cs typeface="Microsoft YaHei"/>
+                        </a:rPr>
+                        <a:t>10 毫秒全局批</a:t>
+                      </a:r>
+                    </a:p>
+                  </a:txBody>
+                  <a:tcPr marL="73152" marR="73152" marT="36576" marB="27432" anchor="ctr">
+                    <a:solidFill>
+                      <a:srgbClr val="0E2A47"/>
+                    </a:solidFill>
+                    <a:lnL w="6350">
+                      <a:solidFill>
+                        <a:srgbClr val="D6DCE2"/>
+                      </a:solidFill>
+                    </a:lnL>
+                    <a:lnR w="6350">
+                      <a:solidFill>
+                        <a:srgbClr val="D6DCE2"/>
+                      </a:solidFill>
+                    </a:lnR>
+                    <a:lnT w="6350">
+                      <a:solidFill>
+                        <a:srgbClr val="D6DCE2"/>
+                      </a:solidFill>
+                    </a:lnT>
+                    <a:lnB w="6350">
+                      <a:solidFill>
+                        <a:srgbClr val="D6DCE2"/>
+                      </a:solidFill>
+                    </a:lnB>
+                  </a:tcPr>
+                </a:tc>
+                <a:tc>
+                  <a:txBody>
+                    <a:bodyPr wrap="square"/>
+                    <a:lstStyle/>
+                    <a:p>
+                      <a:pPr algn="l">
+                        <a:spcBef>
+                          <a:spcPts val="0"/>
+                        </a:spcBef>
+                        <a:spcAft>
+                          <a:spcPts val="0"/>
+                        </a:spcAft>
+                        <a:lnSpc>
+                          <a:spcPct val="100000"/>
+                        </a:lnSpc>
+                      </a:pPr>
+                      <a:r>
+                        <a:rPr sz="1200" b="1">
+                          <a:solidFill>
+                            <a:srgbClr val="FFFFFF"/>
+                          </a:solidFill>
+                          <a:latin typeface="Microsoft YaHei"/>
+                          <a:ea typeface="Microsoft YaHei"/>
+                          <a:cs typeface="Microsoft YaHei"/>
+                        </a:rPr>
+                        <a:t>每卡</a:t>
+                      </a:r>
+                    </a:p>
+                  </a:txBody>
+                  <a:tcPr marL="73152" marR="73152" marT="36576" marB="27432" anchor="ctr">
+                    <a:solidFill>
+                      <a:srgbClr val="0E2A47"/>
+                    </a:solidFill>
+                    <a:lnL w="6350">
+                      <a:solidFill>
+                        <a:srgbClr val="D6DCE2"/>
+                      </a:solidFill>
+                    </a:lnL>
+                    <a:lnR w="6350">
+                      <a:solidFill>
+                        <a:srgbClr val="D6DCE2"/>
+                      </a:solidFill>
+                    </a:lnR>
+                    <a:lnT w="6350">
+                      <a:solidFill>
+                        <a:srgbClr val="D6DCE2"/>
+                      </a:solidFill>
+                    </a:lnT>
+                    <a:lnB w="6350">
+                      <a:solidFill>
+                        <a:srgbClr val="D6DCE2"/>
+                      </a:solidFill>
+                    </a:lnB>
+                  </a:tcPr>
+                </a:tc>
+                <a:tc>
+                  <a:txBody>
+                    <a:bodyPr wrap="square"/>
+                    <a:lstStyle/>
+                    <a:p>
+                      <a:pPr algn="l">
+                        <a:spcBef>
+                          <a:spcPts val="0"/>
+                        </a:spcBef>
+                        <a:spcAft>
+                          <a:spcPts val="0"/>
+                        </a:spcAft>
+                        <a:lnSpc>
+                          <a:spcPct val="100000"/>
+                        </a:lnSpc>
+                      </a:pPr>
+                      <a:r>
+                        <a:rPr sz="1200" b="1">
+                          <a:solidFill>
+                            <a:srgbClr val="FFFFFF"/>
+                          </a:solidFill>
+                          <a:latin typeface="Microsoft YaHei"/>
+                          <a:ea typeface="Microsoft YaHei"/>
+                          <a:cs typeface="Microsoft YaHei"/>
+                        </a:rPr>
+                        <a:t>30 毫秒全局批</a:t>
+                      </a:r>
+                    </a:p>
+                  </a:txBody>
+                  <a:tcPr marL="73152" marR="73152" marT="36576" marB="27432" anchor="ctr">
+                    <a:solidFill>
+                      <a:srgbClr val="0E2A47"/>
+                    </a:solidFill>
+                    <a:lnL w="6350">
+                      <a:solidFill>
+                        <a:srgbClr val="D6DCE2"/>
+                      </a:solidFill>
+                    </a:lnL>
+                    <a:lnR w="6350">
+                      <a:solidFill>
+                        <a:srgbClr val="D6DCE2"/>
+                      </a:solidFill>
+                    </a:lnR>
+                    <a:lnT w="6350">
+                      <a:solidFill>
+                        <a:srgbClr val="D6DCE2"/>
+                      </a:solidFill>
+                    </a:lnT>
+                    <a:lnB w="6350">
+                      <a:solidFill>
+                        <a:srgbClr val="D6DCE2"/>
+                      </a:solidFill>
+                    </a:lnB>
+                  </a:tcPr>
+                </a:tc>
+                <a:tc>
+                  <a:txBody>
+                    <a:bodyPr wrap="square"/>
+                    <a:lstStyle/>
+                    <a:p>
+                      <a:pPr algn="l">
+                        <a:spcBef>
+                          <a:spcPts val="0"/>
+                        </a:spcBef>
+                        <a:spcAft>
+                          <a:spcPts val="0"/>
+                        </a:spcAft>
+                        <a:lnSpc>
+                          <a:spcPct val="100000"/>
+                        </a:lnSpc>
+                      </a:pPr>
+                      <a:r>
+                        <a:rPr sz="1200" b="1">
+                          <a:solidFill>
+                            <a:srgbClr val="FFFFFF"/>
+                          </a:solidFill>
+                          <a:latin typeface="Microsoft YaHei"/>
+                          <a:ea typeface="Microsoft YaHei"/>
+                          <a:cs typeface="Microsoft YaHei"/>
+                        </a:rPr>
+                        <a:t>每卡</a:t>
+                      </a:r>
+                    </a:p>
+                  </a:txBody>
+                  <a:tcPr marL="73152" marR="73152" marT="36576" marB="27432" anchor="ctr">
+                    <a:solidFill>
+                      <a:srgbClr val="0E2A47"/>
+                    </a:solidFill>
+                    <a:lnL w="6350">
+                      <a:solidFill>
+                        <a:srgbClr val="D6DCE2"/>
+                      </a:solidFill>
+                    </a:lnL>
+                    <a:lnR w="6350">
+                      <a:solidFill>
+                        <a:srgbClr val="D6DCE2"/>
+                      </a:solidFill>
+                    </a:lnR>
+                    <a:lnT w="6350">
+                      <a:solidFill>
+                        <a:srgbClr val="D6DCE2"/>
+                      </a:solidFill>
+                    </a:lnT>
+                    <a:lnB w="6350">
+                      <a:solidFill>
+                        <a:srgbClr val="D6DCE2"/>
+                      </a:solidFill>
+                    </a:lnB>
+                  </a:tcPr>
+                </a:tc>
+                <a:tc>
+                  <a:txBody>
+                    <a:bodyPr wrap="square"/>
+                    <a:lstStyle/>
+                    <a:p>
+                      <a:pPr algn="l">
+                        <a:spcBef>
+                          <a:spcPts val="0"/>
+                        </a:spcBef>
+                        <a:spcAft>
+                          <a:spcPts val="0"/>
+                        </a:spcAft>
+                        <a:lnSpc>
+                          <a:spcPct val="100000"/>
+                        </a:lnSpc>
+                      </a:pPr>
+                      <a:r>
+                        <a:rPr sz="1200" b="1">
+                          <a:solidFill>
+                            <a:srgbClr val="FFFFFF"/>
+                          </a:solidFill>
+                          <a:latin typeface="Microsoft YaHei"/>
+                          <a:ea typeface="Microsoft YaHei"/>
+                          <a:cs typeface="Microsoft YaHei"/>
+                        </a:rPr>
+                        <a:t>30 毫秒的 KV 放哪</a:t>
+                      </a:r>
+                    </a:p>
+                  </a:txBody>
+                  <a:tcPr marL="73152" marR="73152" marT="36576" marB="27432" anchor="ctr">
+                    <a:solidFill>
+                      <a:srgbClr val="0E2A47"/>
+                    </a:solidFill>
+                    <a:lnL w="6350">
+                      <a:solidFill>
+                        <a:srgbClr val="D6DCE2"/>
+                      </a:solidFill>
+                    </a:lnL>
+                    <a:lnR w="6350">
+                      <a:solidFill>
+                        <a:srgbClr val="D6DCE2"/>
+                      </a:solidFill>
+                    </a:lnR>
+                    <a:lnT w="6350">
+                      <a:solidFill>
+                        <a:srgbClr val="D6DCE2"/>
+                      </a:solidFill>
+                    </a:lnT>
+                    <a:lnB w="6350">
+                      <a:solidFill>
+                        <a:srgbClr val="D6DCE2"/>
+                      </a:solidFill>
+                    </a:lnB>
+                  </a:tcPr>
+                </a:tc>
+              </a:tr>
+              <a:tr h="475488">
+                <a:tc>
+                  <a:txBody>
+                    <a:bodyPr wrap="square"/>
+                    <a:lstStyle/>
+                    <a:p>
+                      <a:pPr algn="l">
+                        <a:spcBef>
+                          <a:spcPts val="0"/>
+                        </a:spcBef>
+                        <a:spcAft>
+                          <a:spcPts val="0"/>
+                        </a:spcAft>
+                        <a:lnSpc>
+                          <a:spcPct val="100000"/>
+                        </a:lnSpc>
+                      </a:pPr>
+                      <a:r>
+                        <a:rPr sz="1200" b="1">
+                          <a:solidFill>
+                            <a:srgbClr val="0E2A47"/>
+                          </a:solidFill>
+                          <a:latin typeface="Microsoft YaHei"/>
+                          <a:ea typeface="Microsoft YaHei"/>
+                          <a:cs typeface="Microsoft YaHei"/>
+                        </a:rPr>
+                        <a:t>4K</a:t>
+                      </a:r>
+                    </a:p>
+                  </a:txBody>
+                  <a:tcPr marL="73152" marR="73152" marT="36576" marB="27432" anchor="ctr">
+                    <a:solidFill>
+                      <a:srgbClr val="F4F7FA"/>
+                    </a:solidFill>
+                    <a:lnL w="6350">
+                      <a:solidFill>
+                        <a:srgbClr val="D6DCE2"/>
+                      </a:solidFill>
+                    </a:lnL>
+                    <a:lnR w="6350">
+                      <a:solidFill>
+                        <a:srgbClr val="D6DCE2"/>
+                      </a:solidFill>
+                    </a:lnR>
+                    <a:lnT w="6350">
+                      <a:solidFill>
+                        <a:srgbClr val="D6DCE2"/>
+                      </a:solidFill>
+                    </a:lnT>
+                    <a:lnB w="6350">
+                      <a:solidFill>
+                        <a:srgbClr val="D6DCE2"/>
+                      </a:solidFill>
+                    </a:lnB>
+                  </a:tcPr>
+                </a:tc>
+                <a:tc>
+                  <a:txBody>
+                    <a:bodyPr wrap="square"/>
+                    <a:lstStyle/>
+                    <a:p>
+                      <a:pPr algn="l">
+                        <a:spcBef>
+                          <a:spcPts val="0"/>
+                        </a:spcBef>
+                        <a:spcAft>
+                          <a:spcPts val="0"/>
+                        </a:spcAft>
+                        <a:lnSpc>
+                          <a:spcPct val="100000"/>
+                        </a:lnSpc>
+                      </a:pPr>
+                      <a:r>
+                        <a:rPr sz="1200" b="0">
+                          <a:solidFill>
+                            <a:srgbClr val="1C242E"/>
+                          </a:solidFill>
+                          <a:latin typeface="Microsoft YaHei"/>
+                          <a:ea typeface="Microsoft YaHei"/>
+                          <a:cs typeface="Microsoft YaHei"/>
+                        </a:rPr>
+                        <a:t>24.7 MB</a:t>
+                      </a:r>
+                    </a:p>
+                  </a:txBody>
+                  <a:tcPr marL="73152" marR="73152" marT="36576" marB="27432" anchor="ctr">
+                    <a:solidFill>
+                      <a:srgbClr val="FFFFFF"/>
+                    </a:solidFill>
+                    <a:lnL w="6350">
+                      <a:solidFill>
+                        <a:srgbClr val="D6DCE2"/>
+                      </a:solidFill>
+                    </a:lnL>
+                    <a:lnR w="6350">
+                      <a:solidFill>
+                        <a:srgbClr val="D6DCE2"/>
+                      </a:solidFill>
+                    </a:lnR>
+                    <a:lnT w="6350">
+                      <a:solidFill>
+                        <a:srgbClr val="D6DCE2"/>
+                      </a:solidFill>
+                    </a:lnT>
+                    <a:lnB w="6350">
+                      <a:solidFill>
+                        <a:srgbClr val="D6DCE2"/>
+                      </a:solidFill>
+                    </a:lnB>
+                  </a:tcPr>
+                </a:tc>
+                <a:tc>
+                  <a:txBody>
+                    <a:bodyPr wrap="square"/>
+                    <a:lstStyle/>
+                    <a:p>
+                      <a:pPr algn="l">
+                        <a:spcBef>
+                          <a:spcPts val="0"/>
+                        </a:spcBef>
+                        <a:spcAft>
+                          <a:spcPts val="0"/>
+                        </a:spcAft>
+                        <a:lnSpc>
+                          <a:spcPct val="100000"/>
+                        </a:lnSpc>
+                      </a:pPr>
+                      <a:r>
+                        <a:rPr sz="1200" b="0">
+                          <a:solidFill>
+                            <a:srgbClr val="1C242E"/>
+                          </a:solidFill>
+                          <a:latin typeface="Microsoft YaHei"/>
+                          <a:ea typeface="Microsoft YaHei"/>
+                          <a:cs typeface="Microsoft YaHei"/>
+                        </a:rPr>
+                        <a:t>23.1 万</a:t>
+                      </a:r>
+                    </a:p>
+                  </a:txBody>
+                  <a:tcPr marL="73152" marR="73152" marT="36576" marB="27432" anchor="ctr">
+                    <a:solidFill>
+                      <a:srgbClr val="FFFFFF"/>
+                    </a:solidFill>
+                    <a:lnL w="6350">
+                      <a:solidFill>
+                        <a:srgbClr val="D6DCE2"/>
+                      </a:solidFill>
+                    </a:lnL>
+                    <a:lnR w="6350">
+                      <a:solidFill>
+                        <a:srgbClr val="D6DCE2"/>
+                      </a:solidFill>
+                    </a:lnR>
+                    <a:lnT w="6350">
+                      <a:solidFill>
+                        <a:srgbClr val="D6DCE2"/>
+                      </a:solidFill>
+                    </a:lnT>
+                    <a:lnB w="6350">
+                      <a:solidFill>
+                        <a:srgbClr val="D6DCE2"/>
+                      </a:solidFill>
+                    </a:lnB>
+                  </a:tcPr>
+                </a:tc>
+                <a:tc>
+                  <a:txBody>
+                    <a:bodyPr wrap="square"/>
+                    <a:lstStyle/>
+                    <a:p>
+                      <a:pPr algn="l">
+                        <a:spcBef>
+                          <a:spcPts val="0"/>
+                        </a:spcBef>
+                        <a:spcAft>
+                          <a:spcPts val="0"/>
+                        </a:spcAft>
+                        <a:lnSpc>
+                          <a:spcPct val="100000"/>
+                        </a:lnSpc>
+                      </a:pPr>
+                      <a:r>
+                        <a:rPr sz="1200" b="0">
+                          <a:solidFill>
+                            <a:srgbClr val="1C242E"/>
+                          </a:solidFill>
+                          <a:latin typeface="Microsoft YaHei"/>
+                          <a:ea typeface="Microsoft YaHei"/>
+                          <a:cs typeface="Microsoft YaHei"/>
+                        </a:rPr>
+                        <a:t>231</a:t>
+                      </a:r>
+                    </a:p>
+                  </a:txBody>
+                  <a:tcPr marL="73152" marR="73152" marT="36576" marB="27432" anchor="ctr">
+                    <a:solidFill>
+                      <a:srgbClr val="FFFFFF"/>
+                    </a:solidFill>
+                    <a:lnL w="6350">
+                      <a:solidFill>
+                        <a:srgbClr val="D6DCE2"/>
+                      </a:solidFill>
+                    </a:lnL>
+                    <a:lnR w="6350">
+                      <a:solidFill>
+                        <a:srgbClr val="D6DCE2"/>
+                      </a:solidFill>
+                    </a:lnR>
+                    <a:lnT w="6350">
+                      <a:solidFill>
+                        <a:srgbClr val="D6DCE2"/>
+                      </a:solidFill>
+                    </a:lnT>
+                    <a:lnB w="6350">
+                      <a:solidFill>
+                        <a:srgbClr val="D6DCE2"/>
+                      </a:solidFill>
+                    </a:lnB>
+                  </a:tcPr>
+                </a:tc>
+                <a:tc>
+                  <a:txBody>
+                    <a:bodyPr wrap="square"/>
+                    <a:lstStyle/>
+                    <a:p>
+                      <a:pPr algn="l">
+                        <a:spcBef>
+                          <a:spcPts val="0"/>
+                        </a:spcBef>
+                        <a:spcAft>
+                          <a:spcPts val="0"/>
+                        </a:spcAft>
+                        <a:lnSpc>
+                          <a:spcPct val="100000"/>
+                        </a:lnSpc>
+                      </a:pPr>
+                      <a:r>
+                        <a:rPr sz="1200" b="0">
+                          <a:solidFill>
+                            <a:srgbClr val="1C242E"/>
+                          </a:solidFill>
+                          <a:latin typeface="Microsoft YaHei"/>
+                          <a:ea typeface="Microsoft YaHei"/>
+                          <a:cs typeface="Microsoft YaHei"/>
+                        </a:rPr>
+                        <a:t>1.8</a:t>
+                      </a:r>
+                    </a:p>
+                  </a:txBody>
+                  <a:tcPr marL="73152" marR="73152" marT="36576" marB="27432" anchor="ctr">
+                    <a:solidFill>
+                      <a:srgbClr val="FFFFFF"/>
+                    </a:solidFill>
+                    <a:lnL w="6350">
+                      <a:solidFill>
+                        <a:srgbClr val="D6DCE2"/>
+                      </a:solidFill>
+                    </a:lnL>
+                    <a:lnR w="6350">
+                      <a:solidFill>
+                        <a:srgbClr val="D6DCE2"/>
+                      </a:solidFill>
+                    </a:lnR>
+                    <a:lnT w="6350">
+                      <a:solidFill>
+                        <a:srgbClr val="D6DCE2"/>
+                      </a:solidFill>
+                    </a:lnT>
+                    <a:lnB w="6350">
+                      <a:solidFill>
+                        <a:srgbClr val="D6DCE2"/>
+                      </a:solidFill>
+                    </a:lnB>
+                  </a:tcPr>
+                </a:tc>
+                <a:tc>
+                  <a:txBody>
+                    <a:bodyPr wrap="square"/>
+                    <a:lstStyle/>
+                    <a:p>
+                      <a:pPr algn="l">
+                        <a:spcBef>
+                          <a:spcPts val="0"/>
+                        </a:spcBef>
+                        <a:spcAft>
+                          <a:spcPts val="0"/>
+                        </a:spcAft>
+                        <a:lnSpc>
+                          <a:spcPct val="100000"/>
+                        </a:lnSpc>
+                      </a:pPr>
+                      <a:r>
+                        <a:rPr sz="1200" b="0">
+                          <a:solidFill>
+                            <a:srgbClr val="1C242E"/>
+                          </a:solidFill>
+                          <a:latin typeface="Microsoft YaHei"/>
+                          <a:ea typeface="Microsoft YaHei"/>
+                          <a:cs typeface="Microsoft YaHei"/>
+                        </a:rPr>
+                        <a:t>6928</a:t>
+                      </a:r>
+                    </a:p>
+                  </a:txBody>
+                  <a:tcPr marL="73152" marR="73152" marT="36576" marB="27432" anchor="ctr">
+                    <a:solidFill>
+                      <a:srgbClr val="FFFFFF"/>
+                    </a:solidFill>
+                    <a:lnL w="6350">
+                      <a:solidFill>
+                        <a:srgbClr val="D6DCE2"/>
+                      </a:solidFill>
+                    </a:lnL>
+                    <a:lnR w="6350">
+                      <a:solidFill>
+                        <a:srgbClr val="D6DCE2"/>
+                      </a:solidFill>
+                    </a:lnR>
+                    <a:lnT w="6350">
+                      <a:solidFill>
+                        <a:srgbClr val="D6DCE2"/>
+                      </a:solidFill>
+                    </a:lnT>
+                    <a:lnB w="6350">
+                      <a:solidFill>
+                        <a:srgbClr val="D6DCE2"/>
+                      </a:solidFill>
+                    </a:lnB>
+                  </a:tcPr>
+                </a:tc>
+                <a:tc>
+                  <a:txBody>
+                    <a:bodyPr wrap="square"/>
+                    <a:lstStyle/>
+                    <a:p>
+                      <a:pPr algn="l">
+                        <a:spcBef>
+                          <a:spcPts val="0"/>
+                        </a:spcBef>
+                        <a:spcAft>
+                          <a:spcPts val="0"/>
+                        </a:spcAft>
+                        <a:lnSpc>
+                          <a:spcPct val="100000"/>
+                        </a:lnSpc>
+                      </a:pPr>
+                      <a:r>
+                        <a:rPr sz="1200" b="0">
+                          <a:solidFill>
+                            <a:srgbClr val="1C242E"/>
+                          </a:solidFill>
+                          <a:latin typeface="Microsoft YaHei"/>
+                          <a:ea typeface="Microsoft YaHei"/>
+                          <a:cs typeface="Microsoft YaHei"/>
+                        </a:rPr>
+                        <a:t>54.1</a:t>
+                      </a:r>
+                    </a:p>
+                  </a:txBody>
+                  <a:tcPr marL="73152" marR="73152" marT="36576" marB="27432" anchor="ctr">
+                    <a:solidFill>
+                      <a:srgbClr val="FFFFFF"/>
+                    </a:solidFill>
+                    <a:lnL w="6350">
+                      <a:solidFill>
+                        <a:srgbClr val="D6DCE2"/>
+                      </a:solidFill>
+                    </a:lnL>
+                    <a:lnR w="6350">
+                      <a:solidFill>
+                        <a:srgbClr val="D6DCE2"/>
+                      </a:solidFill>
+                    </a:lnR>
+                    <a:lnT w="6350">
+                      <a:solidFill>
+                        <a:srgbClr val="D6DCE2"/>
+                      </a:solidFill>
+                    </a:lnT>
+                    <a:lnB w="6350">
+                      <a:solidFill>
+                        <a:srgbClr val="D6DCE2"/>
+                      </a:solidFill>
+                    </a:lnB>
+                  </a:tcPr>
+                </a:tc>
+                <a:tc>
+                  <a:txBody>
+                    <a:bodyPr wrap="square"/>
+                    <a:lstStyle/>
+                    <a:p>
+                      <a:pPr algn="l">
+                        <a:spcBef>
+                          <a:spcPts val="0"/>
+                        </a:spcBef>
+                        <a:spcAft>
+                          <a:spcPts val="0"/>
+                        </a:spcAft>
+                        <a:lnSpc>
+                          <a:spcPct val="100000"/>
+                        </a:lnSpc>
+                      </a:pPr>
+                      <a:r>
+                        <a:rPr sz="1200" b="0">
+                          <a:solidFill>
+                            <a:srgbClr val="1C242E"/>
+                          </a:solidFill>
+                          <a:latin typeface="Microsoft YaHei"/>
+                          <a:ea typeface="Microsoft YaHei"/>
+                          <a:cs typeface="Microsoft YaHei"/>
+                        </a:rPr>
+                        <a:t>全在 HBM</a:t>
+                      </a:r>
+                    </a:p>
+                  </a:txBody>
+                  <a:tcPr marL="73152" marR="73152" marT="36576" marB="27432" anchor="ctr">
+                    <a:solidFill>
+                      <a:srgbClr val="FFFFFF"/>
+                    </a:solidFill>
+                    <a:lnL w="6350">
+                      <a:solidFill>
+                        <a:srgbClr val="D6DCE2"/>
+                      </a:solidFill>
+                    </a:lnL>
+                    <a:lnR w="6350">
+                      <a:solidFill>
+                        <a:srgbClr val="D6DCE2"/>
+                      </a:solidFill>
+                    </a:lnR>
+                    <a:lnT w="6350">
+                      <a:solidFill>
+                        <a:srgbClr val="D6DCE2"/>
+                      </a:solidFill>
+                    </a:lnT>
+                    <a:lnB w="6350">
+                      <a:solidFill>
+                        <a:srgbClr val="D6DCE2"/>
+                      </a:solidFill>
+                    </a:lnB>
+                  </a:tcPr>
+                </a:tc>
+              </a:tr>
+              <a:tr h="475488">
+                <a:tc>
+                  <a:txBody>
+                    <a:bodyPr wrap="square"/>
+                    <a:lstStyle/>
+                    <a:p>
+                      <a:pPr algn="l">
+                        <a:spcBef>
+                          <a:spcPts val="0"/>
+                        </a:spcBef>
+                        <a:spcAft>
+                          <a:spcPts val="0"/>
+                        </a:spcAft>
+                        <a:lnSpc>
+                          <a:spcPct val="100000"/>
+                        </a:lnSpc>
+                      </a:pPr>
+                      <a:r>
+                        <a:rPr sz="1200" b="1">
+                          <a:solidFill>
+                            <a:srgbClr val="0E2A47"/>
+                          </a:solidFill>
+                          <a:latin typeface="Microsoft YaHei"/>
+                          <a:ea typeface="Microsoft YaHei"/>
+                          <a:cs typeface="Microsoft YaHei"/>
+                        </a:rPr>
+                        <a:t>8K</a:t>
+                      </a:r>
+                    </a:p>
+                  </a:txBody>
+                  <a:tcPr marL="73152" marR="73152" marT="36576" marB="27432" anchor="ctr">
+                    <a:solidFill>
+                      <a:srgbClr val="F4F7FA"/>
+                    </a:solidFill>
+                    <a:lnL w="6350">
+                      <a:solidFill>
+                        <a:srgbClr val="D6DCE2"/>
+                      </a:solidFill>
+                    </a:lnL>
+                    <a:lnR w="6350">
+                      <a:solidFill>
+                        <a:srgbClr val="D6DCE2"/>
+                      </a:solidFill>
+                    </a:lnR>
+                    <a:lnT w="6350">
+                      <a:solidFill>
+                        <a:srgbClr val="D6DCE2"/>
+                      </a:solidFill>
+                    </a:lnT>
+                    <a:lnB w="6350">
+                      <a:solidFill>
+                        <a:srgbClr val="D6DCE2"/>
+                      </a:solidFill>
+                    </a:lnB>
+                  </a:tcPr>
+                </a:tc>
+                <a:tc>
+                  <a:txBody>
+                    <a:bodyPr wrap="square"/>
+                    <a:lstStyle/>
+                    <a:p>
+                      <a:pPr algn="l">
+                        <a:spcBef>
+                          <a:spcPts val="0"/>
+                        </a:spcBef>
+                        <a:spcAft>
+                          <a:spcPts val="0"/>
+                        </a:spcAft>
+                        <a:lnSpc>
+                          <a:spcPct val="100000"/>
+                        </a:lnSpc>
+                      </a:pPr>
+                      <a:r>
+                        <a:rPr sz="1200" b="0">
+                          <a:solidFill>
+                            <a:srgbClr val="1C242E"/>
+                          </a:solidFill>
+                          <a:latin typeface="Microsoft YaHei"/>
+                          <a:ea typeface="Microsoft YaHei"/>
+                          <a:cs typeface="Microsoft YaHei"/>
+                        </a:rPr>
+                        <a:t>45.0 MB</a:t>
+                      </a:r>
+                    </a:p>
+                  </a:txBody>
+                  <a:tcPr marL="73152" marR="73152" marT="36576" marB="27432" anchor="ctr">
+                    <a:solidFill>
+                      <a:srgbClr val="FFFFFF"/>
+                    </a:solidFill>
+                    <a:lnL w="6350">
+                      <a:solidFill>
+                        <a:srgbClr val="D6DCE2"/>
+                      </a:solidFill>
+                    </a:lnL>
+                    <a:lnR w="6350">
+                      <a:solidFill>
+                        <a:srgbClr val="D6DCE2"/>
+                      </a:solidFill>
+                    </a:lnR>
+                    <a:lnT w="6350">
+                      <a:solidFill>
+                        <a:srgbClr val="D6DCE2"/>
+                      </a:solidFill>
+                    </a:lnT>
+                    <a:lnB w="6350">
+                      <a:solidFill>
+                        <a:srgbClr val="D6DCE2"/>
+                      </a:solidFill>
+                    </a:lnB>
+                  </a:tcPr>
+                </a:tc>
+                <a:tc>
+                  <a:txBody>
+                    <a:bodyPr wrap="square"/>
+                    <a:lstStyle/>
+                    <a:p>
+                      <a:pPr algn="l">
+                        <a:spcBef>
+                          <a:spcPts val="0"/>
+                        </a:spcBef>
+                        <a:spcAft>
+                          <a:spcPts val="0"/>
+                        </a:spcAft>
+                        <a:lnSpc>
+                          <a:spcPct val="100000"/>
+                        </a:lnSpc>
+                      </a:pPr>
+                      <a:r>
+                        <a:rPr sz="1200" b="0">
+                          <a:solidFill>
+                            <a:srgbClr val="1C242E"/>
+                          </a:solidFill>
+                          <a:latin typeface="Microsoft YaHei"/>
+                          <a:ea typeface="Microsoft YaHei"/>
+                          <a:cs typeface="Microsoft YaHei"/>
+                        </a:rPr>
+                        <a:t>12.7 万</a:t>
+                      </a:r>
+                    </a:p>
+                  </a:txBody>
+                  <a:tcPr marL="73152" marR="73152" marT="36576" marB="27432" anchor="ctr">
+                    <a:solidFill>
+                      <a:srgbClr val="FFFFFF"/>
+                    </a:solidFill>
+                    <a:lnL w="6350">
+                      <a:solidFill>
+                        <a:srgbClr val="D6DCE2"/>
+                      </a:solidFill>
+                    </a:lnL>
+                    <a:lnR w="6350">
+                      <a:solidFill>
+                        <a:srgbClr val="D6DCE2"/>
+                      </a:solidFill>
+                    </a:lnR>
+                    <a:lnT w="6350">
+                      <a:solidFill>
+                        <a:srgbClr val="D6DCE2"/>
+                      </a:solidFill>
+                    </a:lnT>
+                    <a:lnB w="6350">
+                      <a:solidFill>
+                        <a:srgbClr val="D6DCE2"/>
+                      </a:solidFill>
+                    </a:lnB>
+                  </a:tcPr>
+                </a:tc>
+                <a:tc>
+                  <a:txBody>
+                    <a:bodyPr wrap="square"/>
+                    <a:lstStyle/>
+                    <a:p>
+                      <a:pPr algn="l">
+                        <a:spcBef>
+                          <a:spcPts val="0"/>
+                        </a:spcBef>
+                        <a:spcAft>
+                          <a:spcPts val="0"/>
+                        </a:spcAft>
+                        <a:lnSpc>
+                          <a:spcPct val="100000"/>
+                        </a:lnSpc>
+                      </a:pPr>
+                      <a:r>
+                        <a:rPr sz="1200" b="0">
+                          <a:solidFill>
+                            <a:srgbClr val="1C242E"/>
+                          </a:solidFill>
+                          <a:latin typeface="Microsoft YaHei"/>
+                          <a:ea typeface="Microsoft YaHei"/>
+                          <a:cs typeface="Microsoft YaHei"/>
+                        </a:rPr>
+                        <a:t>231</a:t>
+                      </a:r>
+                    </a:p>
+                  </a:txBody>
+                  <a:tcPr marL="73152" marR="73152" marT="36576" marB="27432" anchor="ctr">
+                    <a:solidFill>
+                      <a:srgbClr val="FFFFFF"/>
+                    </a:solidFill>
+                    <a:lnL w="6350">
+                      <a:solidFill>
+                        <a:srgbClr val="D6DCE2"/>
+                      </a:solidFill>
+                    </a:lnL>
+                    <a:lnR w="6350">
+                      <a:solidFill>
+                        <a:srgbClr val="D6DCE2"/>
+                      </a:solidFill>
+                    </a:lnR>
+                    <a:lnT w="6350">
+                      <a:solidFill>
+                        <a:srgbClr val="D6DCE2"/>
+                      </a:solidFill>
+                    </a:lnT>
+                    <a:lnB w="6350">
+                      <a:solidFill>
+                        <a:srgbClr val="D6DCE2"/>
+                      </a:solidFill>
+                    </a:lnB>
+                  </a:tcPr>
+                </a:tc>
+                <a:tc>
+                  <a:txBody>
+                    <a:bodyPr wrap="square"/>
+                    <a:lstStyle/>
+                    <a:p>
+                      <a:pPr algn="l">
+                        <a:spcBef>
+                          <a:spcPts val="0"/>
+                        </a:spcBef>
+                        <a:spcAft>
+                          <a:spcPts val="0"/>
+                        </a:spcAft>
+                        <a:lnSpc>
+                          <a:spcPct val="100000"/>
+                        </a:lnSpc>
+                      </a:pPr>
+                      <a:r>
+                        <a:rPr sz="1200" b="0">
+                          <a:solidFill>
+                            <a:srgbClr val="1C242E"/>
+                          </a:solidFill>
+                          <a:latin typeface="Microsoft YaHei"/>
+                          <a:ea typeface="Microsoft YaHei"/>
+                          <a:cs typeface="Microsoft YaHei"/>
+                        </a:rPr>
+                        <a:t>1.8</a:t>
+                      </a:r>
+                    </a:p>
+                  </a:txBody>
+                  <a:tcPr marL="73152" marR="73152" marT="36576" marB="27432" anchor="ctr">
+                    <a:solidFill>
+                      <a:srgbClr val="FFFFFF"/>
+                    </a:solidFill>
+                    <a:lnL w="6350">
+                      <a:solidFill>
+                        <a:srgbClr val="D6DCE2"/>
+                      </a:solidFill>
+                    </a:lnL>
+                    <a:lnR w="6350">
+                      <a:solidFill>
+                        <a:srgbClr val="D6DCE2"/>
+                      </a:solidFill>
+                    </a:lnR>
+                    <a:lnT w="6350">
+                      <a:solidFill>
+                        <a:srgbClr val="D6DCE2"/>
+                      </a:solidFill>
+                    </a:lnT>
+                    <a:lnB w="6350">
+                      <a:solidFill>
+                        <a:srgbClr val="D6DCE2"/>
+                      </a:solidFill>
+                    </a:lnB>
+                  </a:tcPr>
+                </a:tc>
+                <a:tc>
+                  <a:txBody>
+                    <a:bodyPr wrap="square"/>
+                    <a:lstStyle/>
+                    <a:p>
+                      <a:pPr algn="l">
+                        <a:spcBef>
+                          <a:spcPts val="0"/>
+                        </a:spcBef>
+                        <a:spcAft>
+                          <a:spcPts val="0"/>
+                        </a:spcAft>
+                        <a:lnSpc>
+                          <a:spcPct val="100000"/>
+                        </a:lnSpc>
+                      </a:pPr>
+                      <a:r>
+                        <a:rPr sz="1200" b="0">
+                          <a:solidFill>
+                            <a:srgbClr val="1C242E"/>
+                          </a:solidFill>
+                          <a:latin typeface="Microsoft YaHei"/>
+                          <a:ea typeface="Microsoft YaHei"/>
+                          <a:cs typeface="Microsoft YaHei"/>
+                        </a:rPr>
+                        <a:t>6928</a:t>
+                      </a:r>
+                    </a:p>
+                  </a:txBody>
+                  <a:tcPr marL="73152" marR="73152" marT="36576" marB="27432" anchor="ctr">
+                    <a:solidFill>
+                      <a:srgbClr val="FFFFFF"/>
+                    </a:solidFill>
+                    <a:lnL w="6350">
+                      <a:solidFill>
+                        <a:srgbClr val="D6DCE2"/>
+                      </a:solidFill>
+                    </a:lnL>
+                    <a:lnR w="6350">
+                      <a:solidFill>
+                        <a:srgbClr val="D6DCE2"/>
+                      </a:solidFill>
+                    </a:lnR>
+                    <a:lnT w="6350">
+                      <a:solidFill>
+                        <a:srgbClr val="D6DCE2"/>
+                      </a:solidFill>
+                    </a:lnT>
+                    <a:lnB w="6350">
+                      <a:solidFill>
+                        <a:srgbClr val="D6DCE2"/>
+                      </a:solidFill>
+                    </a:lnB>
+                  </a:tcPr>
+                </a:tc>
+                <a:tc>
+                  <a:txBody>
+                    <a:bodyPr wrap="square"/>
+                    <a:lstStyle/>
+                    <a:p>
+                      <a:pPr algn="l">
+                        <a:spcBef>
+                          <a:spcPts val="0"/>
+                        </a:spcBef>
+                        <a:spcAft>
+                          <a:spcPts val="0"/>
+                        </a:spcAft>
+                        <a:lnSpc>
+                          <a:spcPct val="100000"/>
+                        </a:lnSpc>
+                      </a:pPr>
+                      <a:r>
+                        <a:rPr sz="1200" b="0">
+                          <a:solidFill>
+                            <a:srgbClr val="1C242E"/>
+                          </a:solidFill>
+                          <a:latin typeface="Microsoft YaHei"/>
+                          <a:ea typeface="Microsoft YaHei"/>
+                          <a:cs typeface="Microsoft YaHei"/>
+                        </a:rPr>
+                        <a:t>54.1</a:t>
+                      </a:r>
+                    </a:p>
+                  </a:txBody>
+                  <a:tcPr marL="73152" marR="73152" marT="36576" marB="27432" anchor="ctr">
+                    <a:solidFill>
+                      <a:srgbClr val="FFFFFF"/>
+                    </a:solidFill>
+                    <a:lnL w="6350">
+                      <a:solidFill>
+                        <a:srgbClr val="D6DCE2"/>
+                      </a:solidFill>
+                    </a:lnL>
+                    <a:lnR w="6350">
+                      <a:solidFill>
+                        <a:srgbClr val="D6DCE2"/>
+                      </a:solidFill>
+                    </a:lnR>
+                    <a:lnT w="6350">
+                      <a:solidFill>
+                        <a:srgbClr val="D6DCE2"/>
+                      </a:solidFill>
+                    </a:lnT>
+                    <a:lnB w="6350">
+                      <a:solidFill>
+                        <a:srgbClr val="D6DCE2"/>
+                      </a:solidFill>
+                    </a:lnB>
+                  </a:tcPr>
+                </a:tc>
+                <a:tc>
+                  <a:txBody>
+                    <a:bodyPr wrap="square"/>
+                    <a:lstStyle/>
+                    <a:p>
+                      <a:pPr algn="l">
+                        <a:spcBef>
+                          <a:spcPts val="0"/>
+                        </a:spcBef>
+                        <a:spcAft>
+                          <a:spcPts val="0"/>
+                        </a:spcAft>
+                        <a:lnSpc>
+                          <a:spcPct val="100000"/>
+                        </a:lnSpc>
+                      </a:pPr>
+                      <a:r>
+                        <a:rPr sz="1200" b="0">
+                          <a:solidFill>
+                            <a:srgbClr val="1C242E"/>
+                          </a:solidFill>
+                          <a:latin typeface="Microsoft YaHei"/>
+                          <a:ea typeface="Microsoft YaHei"/>
+                          <a:cs typeface="Microsoft YaHei"/>
+                        </a:rPr>
+                        <a:t>全在 HBM</a:t>
+                      </a:r>
+                    </a:p>
+                  </a:txBody>
+                  <a:tcPr marL="73152" marR="73152" marT="36576" marB="27432" anchor="ctr">
+                    <a:solidFill>
+                      <a:srgbClr val="FFFFFF"/>
+                    </a:solidFill>
+                    <a:lnL w="6350">
+                      <a:solidFill>
+                        <a:srgbClr val="D6DCE2"/>
+                      </a:solidFill>
+                    </a:lnL>
+                    <a:lnR w="6350">
+                      <a:solidFill>
+                        <a:srgbClr val="D6DCE2"/>
+                      </a:solidFill>
+                    </a:lnR>
+                    <a:lnT w="6350">
+                      <a:solidFill>
+                        <a:srgbClr val="D6DCE2"/>
+                      </a:solidFill>
+                    </a:lnT>
+                    <a:lnB w="6350">
+                      <a:solidFill>
+                        <a:srgbClr val="D6DCE2"/>
+                      </a:solidFill>
+                    </a:lnB>
+                  </a:tcPr>
+                </a:tc>
+              </a:tr>
+              <a:tr h="475488">
+                <a:tc>
+                  <a:txBody>
+                    <a:bodyPr wrap="square"/>
+                    <a:lstStyle/>
+                    <a:p>
+                      <a:pPr algn="l">
+                        <a:spcBef>
+                          <a:spcPts val="0"/>
+                        </a:spcBef>
+                        <a:spcAft>
+                          <a:spcPts val="0"/>
+                        </a:spcAft>
+                        <a:lnSpc>
+                          <a:spcPct val="100000"/>
+                        </a:lnSpc>
+                      </a:pPr>
+                      <a:r>
+                        <a:rPr sz="1200" b="1">
+                          <a:solidFill>
+                            <a:srgbClr val="0E2A47"/>
+                          </a:solidFill>
+                          <a:latin typeface="Microsoft YaHei"/>
+                          <a:ea typeface="Microsoft YaHei"/>
+                          <a:cs typeface="Microsoft YaHei"/>
+                        </a:rPr>
+                        <a:t>32K</a:t>
+                      </a:r>
+                    </a:p>
+                  </a:txBody>
+                  <a:tcPr marL="73152" marR="73152" marT="36576" marB="27432" anchor="ctr">
+                    <a:solidFill>
+                      <a:srgbClr val="F4F7FA"/>
+                    </a:solidFill>
+                    <a:lnL w="6350">
+                      <a:solidFill>
+                        <a:srgbClr val="D6DCE2"/>
+                      </a:solidFill>
+                    </a:lnL>
+                    <a:lnR w="6350">
+                      <a:solidFill>
+                        <a:srgbClr val="D6DCE2"/>
+                      </a:solidFill>
+                    </a:lnR>
+                    <a:lnT w="6350">
+                      <a:solidFill>
+                        <a:srgbClr val="D6DCE2"/>
+                      </a:solidFill>
+                    </a:lnT>
+                    <a:lnB w="6350">
+                      <a:solidFill>
+                        <a:srgbClr val="D6DCE2"/>
+                      </a:solidFill>
+                    </a:lnB>
+                  </a:tcPr>
+                </a:tc>
+                <a:tc>
+                  <a:txBody>
+                    <a:bodyPr wrap="square"/>
+                    <a:lstStyle/>
+                    <a:p>
+                      <a:pPr algn="l">
+                        <a:spcBef>
+                          <a:spcPts val="0"/>
+                        </a:spcBef>
+                        <a:spcAft>
+                          <a:spcPts val="0"/>
+                        </a:spcAft>
+                        <a:lnSpc>
+                          <a:spcPct val="100000"/>
+                        </a:lnSpc>
+                      </a:pPr>
+                      <a:r>
+                        <a:rPr sz="1200" b="0">
+                          <a:solidFill>
+                            <a:srgbClr val="1C242E"/>
+                          </a:solidFill>
+                          <a:latin typeface="Microsoft YaHei"/>
+                          <a:ea typeface="Microsoft YaHei"/>
+                          <a:cs typeface="Microsoft YaHei"/>
+                        </a:rPr>
+                        <a:t>166.4 MB</a:t>
+                      </a:r>
+                    </a:p>
+                  </a:txBody>
+                  <a:tcPr marL="73152" marR="73152" marT="36576" marB="27432" anchor="ctr">
+                    <a:solidFill>
+                      <a:srgbClr val="FFFFFF"/>
+                    </a:solidFill>
+                    <a:lnL w="6350">
+                      <a:solidFill>
+                        <a:srgbClr val="D6DCE2"/>
+                      </a:solidFill>
+                    </a:lnL>
+                    <a:lnR w="6350">
+                      <a:solidFill>
+                        <a:srgbClr val="D6DCE2"/>
+                      </a:solidFill>
+                    </a:lnR>
+                    <a:lnT w="6350">
+                      <a:solidFill>
+                        <a:srgbClr val="D6DCE2"/>
+                      </a:solidFill>
+                    </a:lnT>
+                    <a:lnB w="6350">
+                      <a:solidFill>
+                        <a:srgbClr val="D6DCE2"/>
+                      </a:solidFill>
+                    </a:lnB>
+                  </a:tcPr>
+                </a:tc>
+                <a:tc>
+                  <a:txBody>
+                    <a:bodyPr wrap="square"/>
+                    <a:lstStyle/>
+                    <a:p>
+                      <a:pPr algn="l">
+                        <a:spcBef>
+                          <a:spcPts val="0"/>
+                        </a:spcBef>
+                        <a:spcAft>
+                          <a:spcPts val="0"/>
+                        </a:spcAft>
+                        <a:lnSpc>
+                          <a:spcPct val="100000"/>
+                        </a:lnSpc>
+                      </a:pPr>
+                      <a:r>
+                        <a:rPr sz="1200" b="0">
+                          <a:solidFill>
+                            <a:srgbClr val="1C242E"/>
+                          </a:solidFill>
+                          <a:latin typeface="Microsoft YaHei"/>
+                          <a:ea typeface="Microsoft YaHei"/>
+                          <a:cs typeface="Microsoft YaHei"/>
+                        </a:rPr>
+                        <a:t>3.44 万</a:t>
+                      </a:r>
+                    </a:p>
+                  </a:txBody>
+                  <a:tcPr marL="73152" marR="73152" marT="36576" marB="27432" anchor="ctr">
+                    <a:solidFill>
+                      <a:srgbClr val="FFFFFF"/>
+                    </a:solidFill>
+                    <a:lnL w="6350">
+                      <a:solidFill>
+                        <a:srgbClr val="D6DCE2"/>
+                      </a:solidFill>
+                    </a:lnL>
+                    <a:lnR w="6350">
+                      <a:solidFill>
+                        <a:srgbClr val="D6DCE2"/>
+                      </a:solidFill>
+                    </a:lnR>
+                    <a:lnT w="6350">
+                      <a:solidFill>
+                        <a:srgbClr val="D6DCE2"/>
+                      </a:solidFill>
+                    </a:lnT>
+                    <a:lnB w="6350">
+                      <a:solidFill>
+                        <a:srgbClr val="D6DCE2"/>
+                      </a:solidFill>
+                    </a:lnB>
+                  </a:tcPr>
+                </a:tc>
+                <a:tc>
+                  <a:txBody>
+                    <a:bodyPr wrap="square"/>
+                    <a:lstStyle/>
+                    <a:p>
+                      <a:pPr algn="l">
+                        <a:spcBef>
+                          <a:spcPts val="0"/>
+                        </a:spcBef>
+                        <a:spcAft>
+                          <a:spcPts val="0"/>
+                        </a:spcAft>
+                        <a:lnSpc>
+                          <a:spcPct val="100000"/>
+                        </a:lnSpc>
+                      </a:pPr>
+                      <a:r>
+                        <a:rPr sz="1200" b="0">
+                          <a:solidFill>
+                            <a:srgbClr val="1C242E"/>
+                          </a:solidFill>
+                          <a:latin typeface="Microsoft YaHei"/>
+                          <a:ea typeface="Microsoft YaHei"/>
+                          <a:cs typeface="Microsoft YaHei"/>
+                        </a:rPr>
+                        <a:t>231</a:t>
+                      </a:r>
+                    </a:p>
+                  </a:txBody>
+                  <a:tcPr marL="73152" marR="73152" marT="36576" marB="27432" anchor="ctr">
+                    <a:solidFill>
+                      <a:srgbClr val="FFFFFF"/>
+                    </a:solidFill>
+                    <a:lnL w="6350">
+                      <a:solidFill>
+                        <a:srgbClr val="D6DCE2"/>
+                      </a:solidFill>
+                    </a:lnL>
+                    <a:lnR w="6350">
+                      <a:solidFill>
+                        <a:srgbClr val="D6DCE2"/>
+                      </a:solidFill>
+                    </a:lnR>
+                    <a:lnT w="6350">
+                      <a:solidFill>
+                        <a:srgbClr val="D6DCE2"/>
+                      </a:solidFill>
+                    </a:lnT>
+                    <a:lnB w="6350">
+                      <a:solidFill>
+                        <a:srgbClr val="D6DCE2"/>
+                      </a:solidFill>
+                    </a:lnB>
+                  </a:tcPr>
+                </a:tc>
+                <a:tc>
+                  <a:txBody>
+                    <a:bodyPr wrap="square"/>
+                    <a:lstStyle/>
+                    <a:p>
+                      <a:pPr algn="l">
+                        <a:spcBef>
+                          <a:spcPts val="0"/>
+                        </a:spcBef>
+                        <a:spcAft>
+                          <a:spcPts val="0"/>
+                        </a:spcAft>
+                        <a:lnSpc>
+                          <a:spcPct val="100000"/>
+                        </a:lnSpc>
+                      </a:pPr>
+                      <a:r>
+                        <a:rPr sz="1200" b="0">
+                          <a:solidFill>
+                            <a:srgbClr val="1C242E"/>
+                          </a:solidFill>
+                          <a:latin typeface="Microsoft YaHei"/>
+                          <a:ea typeface="Microsoft YaHei"/>
+                          <a:cs typeface="Microsoft YaHei"/>
+                        </a:rPr>
+                        <a:t>1.8</a:t>
+                      </a:r>
+                    </a:p>
+                  </a:txBody>
+                  <a:tcPr marL="73152" marR="73152" marT="36576" marB="27432" anchor="ctr">
+                    <a:solidFill>
+                      <a:srgbClr val="FFFFFF"/>
+                    </a:solidFill>
+                    <a:lnL w="6350">
+                      <a:solidFill>
+                        <a:srgbClr val="D6DCE2"/>
+                      </a:solidFill>
+                    </a:lnL>
+                    <a:lnR w="6350">
+                      <a:solidFill>
+                        <a:srgbClr val="D6DCE2"/>
+                      </a:solidFill>
+                    </a:lnR>
+                    <a:lnT w="6350">
+                      <a:solidFill>
+                        <a:srgbClr val="D6DCE2"/>
+                      </a:solidFill>
+                    </a:lnT>
+                    <a:lnB w="6350">
+                      <a:solidFill>
+                        <a:srgbClr val="D6DCE2"/>
+                      </a:solidFill>
+                    </a:lnB>
+                  </a:tcPr>
+                </a:tc>
+                <a:tc>
+                  <a:txBody>
+                    <a:bodyPr wrap="square"/>
+                    <a:lstStyle/>
+                    <a:p>
+                      <a:pPr algn="l">
+                        <a:spcBef>
+                          <a:spcPts val="0"/>
+                        </a:spcBef>
+                        <a:spcAft>
+                          <a:spcPts val="0"/>
+                        </a:spcAft>
+                        <a:lnSpc>
+                          <a:spcPct val="100000"/>
+                        </a:lnSpc>
+                      </a:pPr>
+                      <a:r>
+                        <a:rPr sz="1200" b="0">
+                          <a:solidFill>
+                            <a:srgbClr val="1C242E"/>
+                          </a:solidFill>
+                          <a:latin typeface="Microsoft YaHei"/>
+                          <a:ea typeface="Microsoft YaHei"/>
+                          <a:cs typeface="Microsoft YaHei"/>
+                        </a:rPr>
+                        <a:t>6928</a:t>
+                      </a:r>
+                    </a:p>
+                  </a:txBody>
+                  <a:tcPr marL="73152" marR="73152" marT="36576" marB="27432" anchor="ctr">
+                    <a:solidFill>
+                      <a:srgbClr val="FFFFFF"/>
+                    </a:solidFill>
+                    <a:lnL w="6350">
+                      <a:solidFill>
+                        <a:srgbClr val="D6DCE2"/>
+                      </a:solidFill>
+                    </a:lnL>
+                    <a:lnR w="6350">
+                      <a:solidFill>
+                        <a:srgbClr val="D6DCE2"/>
+                      </a:solidFill>
+                    </a:lnR>
+                    <a:lnT w="6350">
+                      <a:solidFill>
+                        <a:srgbClr val="D6DCE2"/>
+                      </a:solidFill>
+                    </a:lnT>
+                    <a:lnB w="6350">
+                      <a:solidFill>
+                        <a:srgbClr val="D6DCE2"/>
+                      </a:solidFill>
+                    </a:lnB>
+                  </a:tcPr>
+                </a:tc>
+                <a:tc>
+                  <a:txBody>
+                    <a:bodyPr wrap="square"/>
+                    <a:lstStyle/>
+                    <a:p>
+                      <a:pPr algn="l">
+                        <a:spcBef>
+                          <a:spcPts val="0"/>
+                        </a:spcBef>
+                        <a:spcAft>
+                          <a:spcPts val="0"/>
+                        </a:spcAft>
+                        <a:lnSpc>
+                          <a:spcPct val="100000"/>
+                        </a:lnSpc>
+                      </a:pPr>
+                      <a:r>
+                        <a:rPr sz="1200" b="0">
+                          <a:solidFill>
+                            <a:srgbClr val="1C242E"/>
+                          </a:solidFill>
+                          <a:latin typeface="Microsoft YaHei"/>
+                          <a:ea typeface="Microsoft YaHei"/>
+                          <a:cs typeface="Microsoft YaHei"/>
+                        </a:rPr>
+                        <a:t>54.1</a:t>
+                      </a:r>
+                    </a:p>
+                  </a:txBody>
+                  <a:tcPr marL="73152" marR="73152" marT="36576" marB="27432" anchor="ctr">
+                    <a:solidFill>
+                      <a:srgbClr val="FFFFFF"/>
+                    </a:solidFill>
+                    <a:lnL w="6350">
+                      <a:solidFill>
+                        <a:srgbClr val="D6DCE2"/>
+                      </a:solidFill>
+                    </a:lnL>
+                    <a:lnR w="6350">
+                      <a:solidFill>
+                        <a:srgbClr val="D6DCE2"/>
+                      </a:solidFill>
+                    </a:lnR>
+                    <a:lnT w="6350">
+                      <a:solidFill>
+                        <a:srgbClr val="D6DCE2"/>
+                      </a:solidFill>
+                    </a:lnT>
+                    <a:lnB w="6350">
+                      <a:solidFill>
+                        <a:srgbClr val="D6DCE2"/>
+                      </a:solidFill>
+                    </a:lnB>
+                  </a:tcPr>
+                </a:tc>
+                <a:tc>
+                  <a:txBody>
+                    <a:bodyPr wrap="square"/>
+                    <a:lstStyle/>
+                    <a:p>
+                      <a:pPr algn="l">
+                        <a:spcBef>
+                          <a:spcPts val="0"/>
+                        </a:spcBef>
+                        <a:spcAft>
+                          <a:spcPts val="0"/>
+                        </a:spcAft>
+                        <a:lnSpc>
+                          <a:spcPct val="100000"/>
+                        </a:lnSpc>
+                      </a:pPr>
+                      <a:r>
+                        <a:rPr sz="1200" b="0">
+                          <a:solidFill>
+                            <a:srgbClr val="1C242E"/>
+                          </a:solidFill>
+                          <a:latin typeface="Microsoft YaHei"/>
+                          <a:ea typeface="Microsoft YaHei"/>
+                          <a:cs typeface="Microsoft YaHei"/>
+                        </a:rPr>
+                        <a:t>全在 HBM</a:t>
+                      </a:r>
+                    </a:p>
+                  </a:txBody>
+                  <a:tcPr marL="73152" marR="73152" marT="36576" marB="27432" anchor="ctr">
+                    <a:solidFill>
+                      <a:srgbClr val="FFFFFF"/>
+                    </a:solidFill>
+                    <a:lnL w="6350">
+                      <a:solidFill>
+                        <a:srgbClr val="D6DCE2"/>
+                      </a:solidFill>
+                    </a:lnL>
+                    <a:lnR w="6350">
+                      <a:solidFill>
+                        <a:srgbClr val="D6DCE2"/>
+                      </a:solidFill>
+                    </a:lnR>
+                    <a:lnT w="6350">
+                      <a:solidFill>
+                        <a:srgbClr val="D6DCE2"/>
+                      </a:solidFill>
+                    </a:lnT>
+                    <a:lnB w="6350">
+                      <a:solidFill>
+                        <a:srgbClr val="D6DCE2"/>
+                      </a:solidFill>
+                    </a:lnB>
+                  </a:tcPr>
+                </a:tc>
+              </a:tr>
+              <a:tr h="475488">
+                <a:tc>
+                  <a:txBody>
+                    <a:bodyPr wrap="square"/>
+                    <a:lstStyle/>
+                    <a:p>
+                      <a:pPr algn="l">
+                        <a:spcBef>
+                          <a:spcPts val="0"/>
+                        </a:spcBef>
+                        <a:spcAft>
+                          <a:spcPts val="0"/>
+                        </a:spcAft>
+                        <a:lnSpc>
+                          <a:spcPct val="100000"/>
+                        </a:lnSpc>
+                      </a:pPr>
+                      <a:r>
+                        <a:rPr sz="1200" b="1">
+                          <a:solidFill>
+                            <a:srgbClr val="0E2A47"/>
+                          </a:solidFill>
+                          <a:latin typeface="Microsoft YaHei"/>
+                          <a:ea typeface="Microsoft YaHei"/>
+                          <a:cs typeface="Microsoft YaHei"/>
+                        </a:rPr>
+                        <a:t>128K</a:t>
+                      </a:r>
+                    </a:p>
+                  </a:txBody>
+                  <a:tcPr marL="73152" marR="73152" marT="36576" marB="27432" anchor="ctr">
+                    <a:solidFill>
+                      <a:srgbClr val="F4F7FA"/>
+                    </a:solidFill>
+                    <a:lnL w="6350">
+                      <a:solidFill>
+                        <a:srgbClr val="D6DCE2"/>
+                      </a:solidFill>
+                    </a:lnL>
+                    <a:lnR w="6350">
+                      <a:solidFill>
+                        <a:srgbClr val="D6DCE2"/>
+                      </a:solidFill>
+                    </a:lnR>
+                    <a:lnT w="6350">
+                      <a:solidFill>
+                        <a:srgbClr val="D6DCE2"/>
+                      </a:solidFill>
+                    </a:lnT>
+                    <a:lnB w="6350">
+                      <a:solidFill>
+                        <a:srgbClr val="D6DCE2"/>
+                      </a:solidFill>
+                    </a:lnB>
+                  </a:tcPr>
+                </a:tc>
+                <a:tc>
+                  <a:txBody>
+                    <a:bodyPr wrap="square"/>
+                    <a:lstStyle/>
+                    <a:p>
+                      <a:pPr algn="l">
+                        <a:spcBef>
+                          <a:spcPts val="0"/>
+                        </a:spcBef>
+                        <a:spcAft>
+                          <a:spcPts val="0"/>
+                        </a:spcAft>
+                        <a:lnSpc>
+                          <a:spcPct val="100000"/>
+                        </a:lnSpc>
+                      </a:pPr>
+                      <a:r>
+                        <a:rPr sz="1200" b="0">
+                          <a:solidFill>
+                            <a:srgbClr val="1C242E"/>
+                          </a:solidFill>
+                          <a:latin typeface="Microsoft YaHei"/>
+                          <a:ea typeface="Microsoft YaHei"/>
+                          <a:cs typeface="Microsoft YaHei"/>
+                        </a:rPr>
+                        <a:t>651.9 MB</a:t>
+                      </a:r>
+                    </a:p>
+                  </a:txBody>
+                  <a:tcPr marL="73152" marR="73152" marT="36576" marB="27432" anchor="ctr">
+                    <a:solidFill>
+                      <a:srgbClr val="FFFFFF"/>
+                    </a:solidFill>
+                    <a:lnL w="6350">
+                      <a:solidFill>
+                        <a:srgbClr val="D6DCE2"/>
+                      </a:solidFill>
+                    </a:lnL>
+                    <a:lnR w="6350">
+                      <a:solidFill>
+                        <a:srgbClr val="D6DCE2"/>
+                      </a:solidFill>
+                    </a:lnR>
+                    <a:lnT w="6350">
+                      <a:solidFill>
+                        <a:srgbClr val="D6DCE2"/>
+                      </a:solidFill>
+                    </a:lnT>
+                    <a:lnB w="6350">
+                      <a:solidFill>
+                        <a:srgbClr val="D6DCE2"/>
+                      </a:solidFill>
+                    </a:lnB>
+                  </a:tcPr>
+                </a:tc>
+                <a:tc>
+                  <a:txBody>
+                    <a:bodyPr wrap="square"/>
+                    <a:lstStyle/>
+                    <a:p>
+                      <a:pPr algn="l">
+                        <a:spcBef>
+                          <a:spcPts val="0"/>
+                        </a:spcBef>
+                        <a:spcAft>
+                          <a:spcPts val="0"/>
+                        </a:spcAft>
+                        <a:lnSpc>
+                          <a:spcPct val="100000"/>
+                        </a:lnSpc>
+                      </a:pPr>
+                      <a:r>
+                        <a:rPr sz="1200" b="0">
+                          <a:solidFill>
+                            <a:srgbClr val="1C242E"/>
+                          </a:solidFill>
+                          <a:latin typeface="Microsoft YaHei"/>
+                          <a:ea typeface="Microsoft YaHei"/>
+                          <a:cs typeface="Microsoft YaHei"/>
+                        </a:rPr>
+                        <a:t>8773</a:t>
+                      </a:r>
+                    </a:p>
+                  </a:txBody>
+                  <a:tcPr marL="73152" marR="73152" marT="36576" marB="27432" anchor="ctr">
+                    <a:solidFill>
+                      <a:srgbClr val="FFFFFF"/>
+                    </a:solidFill>
+                    <a:lnL w="6350">
+                      <a:solidFill>
+                        <a:srgbClr val="D6DCE2"/>
+                      </a:solidFill>
+                    </a:lnL>
+                    <a:lnR w="6350">
+                      <a:solidFill>
+                        <a:srgbClr val="D6DCE2"/>
+                      </a:solidFill>
+                    </a:lnR>
+                    <a:lnT w="6350">
+                      <a:solidFill>
+                        <a:srgbClr val="D6DCE2"/>
+                      </a:solidFill>
+                    </a:lnT>
+                    <a:lnB w="6350">
+                      <a:solidFill>
+                        <a:srgbClr val="D6DCE2"/>
+                      </a:solidFill>
+                    </a:lnB>
+                  </a:tcPr>
+                </a:tc>
+                <a:tc>
+                  <a:txBody>
+                    <a:bodyPr wrap="square"/>
+                    <a:lstStyle/>
+                    <a:p>
+                      <a:pPr algn="l">
+                        <a:spcBef>
+                          <a:spcPts val="0"/>
+                        </a:spcBef>
+                        <a:spcAft>
+                          <a:spcPts val="0"/>
+                        </a:spcAft>
+                        <a:lnSpc>
+                          <a:spcPct val="100000"/>
+                        </a:lnSpc>
+                      </a:pPr>
+                      <a:r>
+                        <a:rPr sz="1200" b="0">
+                          <a:solidFill>
+                            <a:srgbClr val="1C242E"/>
+                          </a:solidFill>
+                          <a:latin typeface="Microsoft YaHei"/>
+                          <a:ea typeface="Microsoft YaHei"/>
+                          <a:cs typeface="Microsoft YaHei"/>
+                        </a:rPr>
+                        <a:t>229</a:t>
+                      </a:r>
+                    </a:p>
+                  </a:txBody>
+                  <a:tcPr marL="73152" marR="73152" marT="36576" marB="27432" anchor="ctr">
+                    <a:solidFill>
+                      <a:srgbClr val="FFFFFF"/>
+                    </a:solidFill>
+                    <a:lnL w="6350">
+                      <a:solidFill>
+                        <a:srgbClr val="D6DCE2"/>
+                      </a:solidFill>
+                    </a:lnL>
+                    <a:lnR w="6350">
+                      <a:solidFill>
+                        <a:srgbClr val="D6DCE2"/>
+                      </a:solidFill>
+                    </a:lnR>
+                    <a:lnT w="6350">
+                      <a:solidFill>
+                        <a:srgbClr val="D6DCE2"/>
+                      </a:solidFill>
+                    </a:lnT>
+                    <a:lnB w="6350">
+                      <a:solidFill>
+                        <a:srgbClr val="D6DCE2"/>
+                      </a:solidFill>
+                    </a:lnB>
+                  </a:tcPr>
+                </a:tc>
+                <a:tc>
+                  <a:txBody>
+                    <a:bodyPr wrap="square"/>
+                    <a:lstStyle/>
+                    <a:p>
+                      <a:pPr algn="l">
+                        <a:spcBef>
+                          <a:spcPts val="0"/>
+                        </a:spcBef>
+                        <a:spcAft>
+                          <a:spcPts val="0"/>
+                        </a:spcAft>
+                        <a:lnSpc>
+                          <a:spcPct val="100000"/>
+                        </a:lnSpc>
+                      </a:pPr>
+                      <a:r>
+                        <a:rPr sz="1200" b="0">
+                          <a:solidFill>
+                            <a:srgbClr val="1C242E"/>
+                          </a:solidFill>
+                          <a:latin typeface="Microsoft YaHei"/>
+                          <a:ea typeface="Microsoft YaHei"/>
+                          <a:cs typeface="Microsoft YaHei"/>
+                        </a:rPr>
+                        <a:t>1.8</a:t>
+                      </a:r>
+                    </a:p>
+                  </a:txBody>
+                  <a:tcPr marL="73152" marR="73152" marT="36576" marB="27432" anchor="ctr">
+                    <a:solidFill>
+                      <a:srgbClr val="FFFFFF"/>
+                    </a:solidFill>
+                    <a:lnL w="6350">
+                      <a:solidFill>
+                        <a:srgbClr val="D6DCE2"/>
+                      </a:solidFill>
+                    </a:lnL>
+                    <a:lnR w="6350">
+                      <a:solidFill>
+                        <a:srgbClr val="D6DCE2"/>
+                      </a:solidFill>
+                    </a:lnR>
+                    <a:lnT w="6350">
+                      <a:solidFill>
+                        <a:srgbClr val="D6DCE2"/>
+                      </a:solidFill>
+                    </a:lnT>
+                    <a:lnB w="6350">
+                      <a:solidFill>
+                        <a:srgbClr val="D6DCE2"/>
+                      </a:solidFill>
+                    </a:lnB>
+                  </a:tcPr>
+                </a:tc>
+                <a:tc>
+                  <a:txBody>
+                    <a:bodyPr wrap="square"/>
+                    <a:lstStyle/>
+                    <a:p>
+                      <a:pPr algn="l">
+                        <a:spcBef>
+                          <a:spcPts val="0"/>
+                        </a:spcBef>
+                        <a:spcAft>
+                          <a:spcPts val="0"/>
+                        </a:spcAft>
+                        <a:lnSpc>
+                          <a:spcPct val="100000"/>
+                        </a:lnSpc>
+                      </a:pPr>
+                      <a:r>
+                        <a:rPr sz="1200" b="0">
+                          <a:solidFill>
+                            <a:srgbClr val="1C242E"/>
+                          </a:solidFill>
+                          <a:latin typeface="Microsoft YaHei"/>
+                          <a:ea typeface="Microsoft YaHei"/>
+                          <a:cs typeface="Microsoft YaHei"/>
+                        </a:rPr>
+                        <a:t>6928</a:t>
+                      </a:r>
+                    </a:p>
+                  </a:txBody>
+                  <a:tcPr marL="73152" marR="73152" marT="36576" marB="27432" anchor="ctr">
+                    <a:solidFill>
+                      <a:srgbClr val="FFFFFF"/>
+                    </a:solidFill>
+                    <a:lnL w="6350">
+                      <a:solidFill>
+                        <a:srgbClr val="D6DCE2"/>
+                      </a:solidFill>
+                    </a:lnL>
+                    <a:lnR w="6350">
+                      <a:solidFill>
+                        <a:srgbClr val="D6DCE2"/>
+                      </a:solidFill>
+                    </a:lnR>
+                    <a:lnT w="6350">
+                      <a:solidFill>
+                        <a:srgbClr val="D6DCE2"/>
+                      </a:solidFill>
+                    </a:lnT>
+                    <a:lnB w="6350">
+                      <a:solidFill>
+                        <a:srgbClr val="D6DCE2"/>
+                      </a:solidFill>
+                    </a:lnB>
+                  </a:tcPr>
+                </a:tc>
+                <a:tc>
+                  <a:txBody>
+                    <a:bodyPr wrap="square"/>
+                    <a:lstStyle/>
+                    <a:p>
+                      <a:pPr algn="l">
+                        <a:spcBef>
+                          <a:spcPts val="0"/>
+                        </a:spcBef>
+                        <a:spcAft>
+                          <a:spcPts val="0"/>
+                        </a:spcAft>
+                        <a:lnSpc>
+                          <a:spcPct val="100000"/>
+                        </a:lnSpc>
+                      </a:pPr>
+                      <a:r>
+                        <a:rPr sz="1200" b="0">
+                          <a:solidFill>
+                            <a:srgbClr val="1C242E"/>
+                          </a:solidFill>
+                          <a:latin typeface="Microsoft YaHei"/>
+                          <a:ea typeface="Microsoft YaHei"/>
+                          <a:cs typeface="Microsoft YaHei"/>
+                        </a:rPr>
+                        <a:t>54.1</a:t>
+                      </a:r>
+                    </a:p>
+                  </a:txBody>
+                  <a:tcPr marL="73152" marR="73152" marT="36576" marB="27432" anchor="ctr">
+                    <a:solidFill>
+                      <a:srgbClr val="FFFFFF"/>
+                    </a:solidFill>
+                    <a:lnL w="6350">
+                      <a:solidFill>
+                        <a:srgbClr val="D6DCE2"/>
+                      </a:solidFill>
+                    </a:lnL>
+                    <a:lnR w="6350">
+                      <a:solidFill>
+                        <a:srgbClr val="D6DCE2"/>
+                      </a:solidFill>
+                    </a:lnR>
+                    <a:lnT w="6350">
+                      <a:solidFill>
+                        <a:srgbClr val="D6DCE2"/>
+                      </a:solidFill>
+                    </a:lnT>
+                    <a:lnB w="6350">
+                      <a:solidFill>
+                        <a:srgbClr val="D6DCE2"/>
+                      </a:solidFill>
+                    </a:lnB>
+                  </a:tcPr>
+                </a:tc>
+                <a:tc>
+                  <a:txBody>
+                    <a:bodyPr wrap="square"/>
+                    <a:lstStyle/>
+                    <a:p>
+                      <a:pPr algn="l">
+                        <a:spcBef>
+                          <a:spcPts val="0"/>
+                        </a:spcBef>
+                        <a:spcAft>
+                          <a:spcPts val="0"/>
+                        </a:spcAft>
+                        <a:lnSpc>
+                          <a:spcPct val="100000"/>
+                        </a:lnSpc>
+                      </a:pPr>
+                      <a:r>
+                        <a:rPr sz="1200" b="0">
+                          <a:solidFill>
+                            <a:srgbClr val="1C242E"/>
+                          </a:solidFill>
+                          <a:latin typeface="Microsoft YaHei"/>
+                          <a:ea typeface="Microsoft YaHei"/>
+                          <a:cs typeface="Microsoft YaHei"/>
+                        </a:rPr>
+                        <a:t>全在 HBM</a:t>
+                      </a:r>
+                    </a:p>
+                  </a:txBody>
+                  <a:tcPr marL="73152" marR="73152" marT="36576" marB="27432" anchor="ctr">
+                    <a:solidFill>
+                      <a:srgbClr val="FFFFFF"/>
+                    </a:solidFill>
+                    <a:lnL w="6350">
+                      <a:solidFill>
+                        <a:srgbClr val="D6DCE2"/>
+                      </a:solidFill>
+                    </a:lnL>
+                    <a:lnR w="6350">
+                      <a:solidFill>
+                        <a:srgbClr val="D6DCE2"/>
+                      </a:solidFill>
+                    </a:lnR>
+                    <a:lnT w="6350">
+                      <a:solidFill>
+                        <a:srgbClr val="D6DCE2"/>
+                      </a:solidFill>
+                    </a:lnT>
+                    <a:lnB w="6350">
+                      <a:solidFill>
+                        <a:srgbClr val="D6DCE2"/>
+                      </a:solidFill>
+                    </a:lnB>
+                  </a:tcPr>
+                </a:tc>
+              </a:tr>
+              <a:tr h="475488">
+                <a:tc>
+                  <a:txBody>
+                    <a:bodyPr wrap="square"/>
+                    <a:lstStyle/>
+                    <a:p>
+                      <a:pPr algn="l">
+                        <a:spcBef>
+                          <a:spcPts val="0"/>
+                        </a:spcBef>
+                        <a:spcAft>
+                          <a:spcPts val="0"/>
+                        </a:spcAft>
+                        <a:lnSpc>
+                          <a:spcPct val="100000"/>
+                        </a:lnSpc>
+                      </a:pPr>
+                      <a:r>
+                        <a:rPr sz="1200" b="1">
+                          <a:solidFill>
+                            <a:srgbClr val="0E7A76"/>
+                          </a:solidFill>
+                          <a:latin typeface="Microsoft YaHei"/>
+                          <a:ea typeface="Microsoft YaHei"/>
+                          <a:cs typeface="Microsoft YaHei"/>
+                        </a:rPr>
+                        <a:t>256K</a:t>
+                      </a:r>
+                    </a:p>
+                  </a:txBody>
+                  <a:tcPr marL="73152" marR="73152" marT="36576" marB="27432" anchor="ctr">
+                    <a:solidFill>
+                      <a:srgbClr val="F4F7FA"/>
+                    </a:solidFill>
+                    <a:lnL w="6350">
+                      <a:solidFill>
+                        <a:srgbClr val="D6DCE2"/>
+                      </a:solidFill>
+                    </a:lnL>
+                    <a:lnR w="6350">
+                      <a:solidFill>
+                        <a:srgbClr val="D6DCE2"/>
+                      </a:solidFill>
+                    </a:lnR>
+                    <a:lnT w="6350">
+                      <a:solidFill>
+                        <a:srgbClr val="D6DCE2"/>
+                      </a:solidFill>
+                    </a:lnT>
+                    <a:lnB w="6350">
+                      <a:solidFill>
+                        <a:srgbClr val="D6DCE2"/>
+                      </a:solidFill>
+                    </a:lnB>
+                  </a:tcPr>
+                </a:tc>
+                <a:tc>
+                  <a:txBody>
+                    <a:bodyPr wrap="square"/>
+                    <a:lstStyle/>
+                    <a:p>
+                      <a:pPr algn="l">
+                        <a:spcBef>
+                          <a:spcPts val="0"/>
+                        </a:spcBef>
+                        <a:spcAft>
+                          <a:spcPts val="0"/>
+                        </a:spcAft>
+                        <a:lnSpc>
+                          <a:spcPct val="100000"/>
+                        </a:lnSpc>
+                      </a:pPr>
+                      <a:r>
+                        <a:rPr sz="1200" b="1">
+                          <a:solidFill>
+                            <a:srgbClr val="0E7A76"/>
+                          </a:solidFill>
+                          <a:latin typeface="Microsoft YaHei"/>
+                          <a:ea typeface="Microsoft YaHei"/>
+                          <a:cs typeface="Microsoft YaHei"/>
+                        </a:rPr>
+                        <a:t>1.30 GB</a:t>
+                      </a:r>
+                    </a:p>
+                  </a:txBody>
+                  <a:tcPr marL="73152" marR="73152" marT="36576" marB="27432" anchor="ctr">
+                    <a:solidFill>
+                      <a:srgbClr val="E7F3F2"/>
+                    </a:solidFill>
+                    <a:lnL w="6350">
+                      <a:solidFill>
+                        <a:srgbClr val="D6DCE2"/>
+                      </a:solidFill>
+                    </a:lnL>
+                    <a:lnR w="6350">
+                      <a:solidFill>
+                        <a:srgbClr val="D6DCE2"/>
+                      </a:solidFill>
+                    </a:lnR>
+                    <a:lnT w="6350">
+                      <a:solidFill>
+                        <a:srgbClr val="D6DCE2"/>
+                      </a:solidFill>
+                    </a:lnT>
+                    <a:lnB w="6350">
+                      <a:solidFill>
+                        <a:srgbClr val="D6DCE2"/>
+                      </a:solidFill>
+                    </a:lnB>
+                  </a:tcPr>
+                </a:tc>
+                <a:tc>
+                  <a:txBody>
+                    <a:bodyPr wrap="square"/>
+                    <a:lstStyle/>
+                    <a:p>
+                      <a:pPr algn="l">
+                        <a:spcBef>
+                          <a:spcPts val="0"/>
+                        </a:spcBef>
+                        <a:spcAft>
+                          <a:spcPts val="0"/>
+                        </a:spcAft>
+                        <a:lnSpc>
+                          <a:spcPct val="100000"/>
+                        </a:lnSpc>
+                      </a:pPr>
+                      <a:r>
+                        <a:rPr sz="1200" b="1">
+                          <a:solidFill>
+                            <a:srgbClr val="0E7A76"/>
+                          </a:solidFill>
+                          <a:latin typeface="Microsoft YaHei"/>
+                          <a:ea typeface="Microsoft YaHei"/>
+                          <a:cs typeface="Microsoft YaHei"/>
+                        </a:rPr>
+                        <a:t>4402</a:t>
+                      </a:r>
+                    </a:p>
+                  </a:txBody>
+                  <a:tcPr marL="73152" marR="73152" marT="36576" marB="27432" anchor="ctr">
+                    <a:solidFill>
+                      <a:srgbClr val="E7F3F2"/>
+                    </a:solidFill>
+                    <a:lnL w="6350">
+                      <a:solidFill>
+                        <a:srgbClr val="D6DCE2"/>
+                      </a:solidFill>
+                    </a:lnL>
+                    <a:lnR w="6350">
+                      <a:solidFill>
+                        <a:srgbClr val="D6DCE2"/>
+                      </a:solidFill>
+                    </a:lnR>
+                    <a:lnT w="6350">
+                      <a:solidFill>
+                        <a:srgbClr val="D6DCE2"/>
+                      </a:solidFill>
+                    </a:lnT>
+                    <a:lnB w="6350">
+                      <a:solidFill>
+                        <a:srgbClr val="D6DCE2"/>
+                      </a:solidFill>
+                    </a:lnB>
+                  </a:tcPr>
+                </a:tc>
+                <a:tc>
+                  <a:txBody>
+                    <a:bodyPr wrap="square"/>
+                    <a:lstStyle/>
+                    <a:p>
+                      <a:pPr algn="l">
+                        <a:spcBef>
+                          <a:spcPts val="0"/>
+                        </a:spcBef>
+                        <a:spcAft>
+                          <a:spcPts val="0"/>
+                        </a:spcAft>
+                        <a:lnSpc>
+                          <a:spcPct val="100000"/>
+                        </a:lnSpc>
+                      </a:pPr>
+                      <a:r>
+                        <a:rPr sz="1200" b="1">
+                          <a:solidFill>
+                            <a:srgbClr val="0E7A76"/>
+                          </a:solidFill>
+                          <a:latin typeface="Microsoft YaHei"/>
+                          <a:ea typeface="Microsoft YaHei"/>
+                          <a:cs typeface="Microsoft YaHei"/>
+                        </a:rPr>
+                        <a:t>226</a:t>
+                      </a:r>
+                    </a:p>
+                  </a:txBody>
+                  <a:tcPr marL="73152" marR="73152" marT="36576" marB="27432" anchor="ctr">
+                    <a:solidFill>
+                      <a:srgbClr val="E7F3F2"/>
+                    </a:solidFill>
+                    <a:lnL w="6350">
+                      <a:solidFill>
+                        <a:srgbClr val="D6DCE2"/>
+                      </a:solidFill>
+                    </a:lnL>
+                    <a:lnR w="6350">
+                      <a:solidFill>
+                        <a:srgbClr val="D6DCE2"/>
+                      </a:solidFill>
+                    </a:lnR>
+                    <a:lnT w="6350">
+                      <a:solidFill>
+                        <a:srgbClr val="D6DCE2"/>
+                      </a:solidFill>
+                    </a:lnT>
+                    <a:lnB w="6350">
+                      <a:solidFill>
+                        <a:srgbClr val="D6DCE2"/>
+                      </a:solidFill>
+                    </a:lnB>
+                  </a:tcPr>
+                </a:tc>
+                <a:tc>
+                  <a:txBody>
+                    <a:bodyPr wrap="square"/>
+                    <a:lstStyle/>
+                    <a:p>
+                      <a:pPr algn="l">
+                        <a:spcBef>
+                          <a:spcPts val="0"/>
+                        </a:spcBef>
+                        <a:spcAft>
+                          <a:spcPts val="0"/>
+                        </a:spcAft>
+                        <a:lnSpc>
+                          <a:spcPct val="100000"/>
+                        </a:lnSpc>
+                      </a:pPr>
+                      <a:r>
+                        <a:rPr sz="1200" b="1">
+                          <a:solidFill>
+                            <a:srgbClr val="0E7A76"/>
+                          </a:solidFill>
+                          <a:latin typeface="Microsoft YaHei"/>
+                          <a:ea typeface="Microsoft YaHei"/>
+                          <a:cs typeface="Microsoft YaHei"/>
+                        </a:rPr>
+                        <a:t>1.8</a:t>
+                      </a:r>
+                    </a:p>
+                  </a:txBody>
+                  <a:tcPr marL="73152" marR="73152" marT="36576" marB="27432" anchor="ctr">
+                    <a:solidFill>
+                      <a:srgbClr val="E7F3F2"/>
+                    </a:solidFill>
+                    <a:lnL w="6350">
+                      <a:solidFill>
+                        <a:srgbClr val="D6DCE2"/>
+                      </a:solidFill>
+                    </a:lnL>
+                    <a:lnR w="6350">
+                      <a:solidFill>
+                        <a:srgbClr val="D6DCE2"/>
+                      </a:solidFill>
+                    </a:lnR>
+                    <a:lnT w="6350">
+                      <a:solidFill>
+                        <a:srgbClr val="D6DCE2"/>
+                      </a:solidFill>
+                    </a:lnT>
+                    <a:lnB w="6350">
+                      <a:solidFill>
+                        <a:srgbClr val="D6DCE2"/>
+                      </a:solidFill>
+                    </a:lnB>
+                  </a:tcPr>
+                </a:tc>
+                <a:tc>
+                  <a:txBody>
+                    <a:bodyPr wrap="square"/>
+                    <a:lstStyle/>
+                    <a:p>
+                      <a:pPr algn="l">
+                        <a:spcBef>
+                          <a:spcPts val="0"/>
+                        </a:spcBef>
+                        <a:spcAft>
+                          <a:spcPts val="0"/>
+                        </a:spcAft>
+                        <a:lnSpc>
+                          <a:spcPct val="100000"/>
+                        </a:lnSpc>
+                      </a:pPr>
+                      <a:r>
+                        <a:rPr sz="1200" b="1">
+                          <a:solidFill>
+                            <a:srgbClr val="0E7A76"/>
+                          </a:solidFill>
+                          <a:latin typeface="Microsoft YaHei"/>
+                          <a:ea typeface="Microsoft YaHei"/>
+                          <a:cs typeface="Microsoft YaHei"/>
+                        </a:rPr>
+                        <a:t>4991</a:t>
+                      </a:r>
+                    </a:p>
+                  </a:txBody>
+                  <a:tcPr marL="73152" marR="73152" marT="36576" marB="27432" anchor="ctr">
+                    <a:solidFill>
+                      <a:srgbClr val="E7F3F2"/>
+                    </a:solidFill>
+                    <a:lnL w="6350">
+                      <a:solidFill>
+                        <a:srgbClr val="D6DCE2"/>
+                      </a:solidFill>
+                    </a:lnL>
+                    <a:lnR w="6350">
+                      <a:solidFill>
+                        <a:srgbClr val="D6DCE2"/>
+                      </a:solidFill>
+                    </a:lnR>
+                    <a:lnT w="6350">
+                      <a:solidFill>
+                        <a:srgbClr val="D6DCE2"/>
+                      </a:solidFill>
+                    </a:lnT>
+                    <a:lnB w="6350">
+                      <a:solidFill>
+                        <a:srgbClr val="D6DCE2"/>
+                      </a:solidFill>
+                    </a:lnB>
+                  </a:tcPr>
+                </a:tc>
+                <a:tc>
+                  <a:txBody>
+                    <a:bodyPr wrap="square"/>
+                    <a:lstStyle/>
+                    <a:p>
+                      <a:pPr algn="l">
+                        <a:spcBef>
+                          <a:spcPts val="0"/>
+                        </a:spcBef>
+                        <a:spcAft>
+                          <a:spcPts val="0"/>
+                        </a:spcAft>
+                        <a:lnSpc>
+                          <a:spcPct val="100000"/>
+                        </a:lnSpc>
+                      </a:pPr>
+                      <a:r>
+                        <a:rPr sz="1200" b="1">
+                          <a:solidFill>
+                            <a:srgbClr val="0E7A76"/>
+                          </a:solidFill>
+                          <a:latin typeface="Microsoft YaHei"/>
+                          <a:ea typeface="Microsoft YaHei"/>
+                          <a:cs typeface="Microsoft YaHei"/>
+                        </a:rPr>
+                        <a:t>39.0</a:t>
+                      </a:r>
+                    </a:p>
+                  </a:txBody>
+                  <a:tcPr marL="73152" marR="73152" marT="36576" marB="27432" anchor="ctr">
+                    <a:solidFill>
+                      <a:srgbClr val="E7F3F2"/>
+                    </a:solidFill>
+                    <a:lnL w="6350">
+                      <a:solidFill>
+                        <a:srgbClr val="D6DCE2"/>
+                      </a:solidFill>
+                    </a:lnL>
+                    <a:lnR w="6350">
+                      <a:solidFill>
+                        <a:srgbClr val="D6DCE2"/>
+                      </a:solidFill>
+                    </a:lnR>
+                    <a:lnT w="6350">
+                      <a:solidFill>
+                        <a:srgbClr val="D6DCE2"/>
+                      </a:solidFill>
+                    </a:lnT>
+                    <a:lnB w="6350">
+                      <a:solidFill>
+                        <a:srgbClr val="D6DCE2"/>
+                      </a:solidFill>
+                    </a:lnB>
+                  </a:tcPr>
+                </a:tc>
+                <a:tc>
+                  <a:txBody>
+                    <a:bodyPr wrap="square"/>
+                    <a:lstStyle/>
+                    <a:p>
+                      <a:pPr algn="l">
+                        <a:spcBef>
+                          <a:spcPts val="0"/>
+                        </a:spcBef>
+                        <a:spcAft>
+                          <a:spcPts val="0"/>
+                        </a:spcAft>
+                        <a:lnSpc>
+                          <a:spcPct val="100000"/>
+                        </a:lnSpc>
+                      </a:pPr>
+                      <a:r>
+                        <a:rPr sz="1200" b="1">
+                          <a:solidFill>
+                            <a:srgbClr val="0E7A76"/>
+                          </a:solidFill>
+                          <a:latin typeface="Microsoft YaHei"/>
+                          <a:ea typeface="Microsoft YaHei"/>
+                          <a:cs typeface="Microsoft YaHei"/>
+                        </a:rPr>
+                        <a:t>12% 经本卡 H2D</a:t>
+                      </a:r>
+                    </a:p>
+                  </a:txBody>
+                  <a:tcPr marL="73152" marR="73152" marT="36576" marB="27432" anchor="ctr">
+                    <a:solidFill>
+                      <a:srgbClr val="E7F3F2"/>
+                    </a:solidFill>
+                    <a:lnL w="6350">
+                      <a:solidFill>
+                        <a:srgbClr val="D6DCE2"/>
+                      </a:solidFill>
+                    </a:lnL>
+                    <a:lnR w="6350">
+                      <a:solidFill>
+                        <a:srgbClr val="D6DCE2"/>
+                      </a:solidFill>
+                    </a:lnR>
+                    <a:lnT w="6350">
+                      <a:solidFill>
+                        <a:srgbClr val="D6DCE2"/>
+                      </a:solidFill>
+                    </a:lnT>
+                    <a:lnB w="6350">
+                      <a:solidFill>
+                        <a:srgbClr val="D6DCE2"/>
+                      </a:solidFill>
+                    </a:lnB>
+                  </a:tcPr>
+                </a:tc>
+              </a:tr>
+              <a:tr h="475488">
+                <a:tc>
+                  <a:txBody>
+                    <a:bodyPr wrap="square"/>
+                    <a:lstStyle/>
+                    <a:p>
+                      <a:pPr algn="l">
+                        <a:spcBef>
+                          <a:spcPts val="0"/>
+                        </a:spcBef>
+                        <a:spcAft>
+                          <a:spcPts val="0"/>
+                        </a:spcAft>
+                        <a:lnSpc>
+                          <a:spcPct val="100000"/>
+                        </a:lnSpc>
+                      </a:pPr>
+                      <a:r>
+                        <a:rPr sz="1200" b="1">
+                          <a:solidFill>
+                            <a:srgbClr val="0E7A76"/>
+                          </a:solidFill>
+                          <a:latin typeface="Microsoft YaHei"/>
+                          <a:ea typeface="Microsoft YaHei"/>
+                          <a:cs typeface="Microsoft YaHei"/>
+                        </a:rPr>
+                        <a:t>512K</a:t>
+                      </a:r>
+                    </a:p>
+                  </a:txBody>
+                  <a:tcPr marL="73152" marR="73152" marT="36576" marB="27432" anchor="ctr">
+                    <a:solidFill>
+                      <a:srgbClr val="F4F7FA"/>
+                    </a:solidFill>
+                    <a:lnL w="6350">
+                      <a:solidFill>
+                        <a:srgbClr val="D6DCE2"/>
+                      </a:solidFill>
+                    </a:lnL>
+                    <a:lnR w="6350">
+                      <a:solidFill>
+                        <a:srgbClr val="D6DCE2"/>
+                      </a:solidFill>
+                    </a:lnR>
+                    <a:lnT w="6350">
+                      <a:solidFill>
+                        <a:srgbClr val="D6DCE2"/>
+                      </a:solidFill>
+                    </a:lnT>
+                    <a:lnB w="6350">
+                      <a:solidFill>
+                        <a:srgbClr val="D6DCE2"/>
+                      </a:solidFill>
+                    </a:lnB>
+                  </a:tcPr>
+                </a:tc>
+                <a:tc>
+                  <a:txBody>
+                    <a:bodyPr wrap="square"/>
+                    <a:lstStyle/>
+                    <a:p>
+                      <a:pPr algn="l">
+                        <a:spcBef>
+                          <a:spcPts val="0"/>
+                        </a:spcBef>
+                        <a:spcAft>
+                          <a:spcPts val="0"/>
+                        </a:spcAft>
+                        <a:lnSpc>
+                          <a:spcPct val="100000"/>
+                        </a:lnSpc>
+                      </a:pPr>
+                      <a:r>
+                        <a:rPr sz="1200" b="1">
+                          <a:solidFill>
+                            <a:srgbClr val="0E7A76"/>
+                          </a:solidFill>
+                          <a:latin typeface="Microsoft YaHei"/>
+                          <a:ea typeface="Microsoft YaHei"/>
+                          <a:cs typeface="Microsoft YaHei"/>
+                        </a:rPr>
+                        <a:t>2.59 GB</a:t>
+                      </a:r>
+                    </a:p>
+                  </a:txBody>
+                  <a:tcPr marL="73152" marR="73152" marT="36576" marB="27432" anchor="ctr">
+                    <a:solidFill>
+                      <a:srgbClr val="E7F3F2"/>
+                    </a:solidFill>
+                    <a:lnL w="6350">
+                      <a:solidFill>
+                        <a:srgbClr val="D6DCE2"/>
+                      </a:solidFill>
+                    </a:lnL>
+                    <a:lnR w="6350">
+                      <a:solidFill>
+                        <a:srgbClr val="D6DCE2"/>
+                      </a:solidFill>
+                    </a:lnR>
+                    <a:lnT w="6350">
+                      <a:solidFill>
+                        <a:srgbClr val="D6DCE2"/>
+                      </a:solidFill>
+                    </a:lnT>
+                    <a:lnB w="6350">
+                      <a:solidFill>
+                        <a:srgbClr val="D6DCE2"/>
+                      </a:solidFill>
+                    </a:lnB>
+                  </a:tcPr>
+                </a:tc>
+                <a:tc>
+                  <a:txBody>
+                    <a:bodyPr wrap="square"/>
+                    <a:lstStyle/>
+                    <a:p>
+                      <a:pPr algn="l">
+                        <a:spcBef>
+                          <a:spcPts val="0"/>
+                        </a:spcBef>
+                        <a:spcAft>
+                          <a:spcPts val="0"/>
+                        </a:spcAft>
+                        <a:lnSpc>
+                          <a:spcPct val="100000"/>
+                        </a:lnSpc>
+                      </a:pPr>
+                      <a:r>
+                        <a:rPr sz="1200" b="1">
+                          <a:solidFill>
+                            <a:srgbClr val="0E7A76"/>
+                          </a:solidFill>
+                          <a:latin typeface="Microsoft YaHei"/>
+                          <a:ea typeface="Microsoft YaHei"/>
+                          <a:cs typeface="Microsoft YaHei"/>
+                        </a:rPr>
+                        <a:t>2204</a:t>
+                      </a:r>
+                    </a:p>
+                  </a:txBody>
+                  <a:tcPr marL="73152" marR="73152" marT="36576" marB="27432" anchor="ctr">
+                    <a:solidFill>
+                      <a:srgbClr val="E7F3F2"/>
+                    </a:solidFill>
+                    <a:lnL w="6350">
+                      <a:solidFill>
+                        <a:srgbClr val="D6DCE2"/>
+                      </a:solidFill>
+                    </a:lnL>
+                    <a:lnR w="6350">
+                      <a:solidFill>
+                        <a:srgbClr val="D6DCE2"/>
+                      </a:solidFill>
+                    </a:lnR>
+                    <a:lnT w="6350">
+                      <a:solidFill>
+                        <a:srgbClr val="D6DCE2"/>
+                      </a:solidFill>
+                    </a:lnT>
+                    <a:lnB w="6350">
+                      <a:solidFill>
+                        <a:srgbClr val="D6DCE2"/>
+                      </a:solidFill>
+                    </a:lnB>
+                  </a:tcPr>
+                </a:tc>
+                <a:tc>
+                  <a:txBody>
+                    <a:bodyPr wrap="square"/>
+                    <a:lstStyle/>
+                    <a:p>
+                      <a:pPr algn="l">
+                        <a:spcBef>
+                          <a:spcPts val="0"/>
+                        </a:spcBef>
+                        <a:spcAft>
+                          <a:spcPts val="0"/>
+                        </a:spcAft>
+                        <a:lnSpc>
+                          <a:spcPct val="100000"/>
+                        </a:lnSpc>
+                      </a:pPr>
+                      <a:r>
+                        <a:rPr sz="1200" b="1">
+                          <a:solidFill>
+                            <a:srgbClr val="0E7A76"/>
+                          </a:solidFill>
+                          <a:latin typeface="Microsoft YaHei"/>
+                          <a:ea typeface="Microsoft YaHei"/>
+                          <a:cs typeface="Microsoft YaHei"/>
+                        </a:rPr>
+                        <a:t>222</a:t>
+                      </a:r>
+                    </a:p>
+                  </a:txBody>
+                  <a:tcPr marL="73152" marR="73152" marT="36576" marB="27432" anchor="ctr">
+                    <a:solidFill>
+                      <a:srgbClr val="E7F3F2"/>
+                    </a:solidFill>
+                    <a:lnL w="6350">
+                      <a:solidFill>
+                        <a:srgbClr val="D6DCE2"/>
+                      </a:solidFill>
+                    </a:lnL>
+                    <a:lnR w="6350">
+                      <a:solidFill>
+                        <a:srgbClr val="D6DCE2"/>
+                      </a:solidFill>
+                    </a:lnR>
+                    <a:lnT w="6350">
+                      <a:solidFill>
+                        <a:srgbClr val="D6DCE2"/>
+                      </a:solidFill>
+                    </a:lnT>
+                    <a:lnB w="6350">
+                      <a:solidFill>
+                        <a:srgbClr val="D6DCE2"/>
+                      </a:solidFill>
+                    </a:lnB>
+                  </a:tcPr>
+                </a:tc>
+                <a:tc>
+                  <a:txBody>
+                    <a:bodyPr wrap="square"/>
+                    <a:lstStyle/>
+                    <a:p>
+                      <a:pPr algn="l">
+                        <a:spcBef>
+                          <a:spcPts val="0"/>
+                        </a:spcBef>
+                        <a:spcAft>
+                          <a:spcPts val="0"/>
+                        </a:spcAft>
+                        <a:lnSpc>
+                          <a:spcPct val="100000"/>
+                        </a:lnSpc>
+                      </a:pPr>
+                      <a:r>
+                        <a:rPr sz="1200" b="1">
+                          <a:solidFill>
+                            <a:srgbClr val="0E7A76"/>
+                          </a:solidFill>
+                          <a:latin typeface="Microsoft YaHei"/>
+                          <a:ea typeface="Microsoft YaHei"/>
+                          <a:cs typeface="Microsoft YaHei"/>
+                        </a:rPr>
+                        <a:t>1.7</a:t>
+                      </a:r>
+                    </a:p>
+                  </a:txBody>
+                  <a:tcPr marL="73152" marR="73152" marT="36576" marB="27432" anchor="ctr">
+                    <a:solidFill>
+                      <a:srgbClr val="E7F3F2"/>
+                    </a:solidFill>
+                    <a:lnL w="6350">
+                      <a:solidFill>
+                        <a:srgbClr val="D6DCE2"/>
+                      </a:solidFill>
+                    </a:lnL>
+                    <a:lnR w="6350">
+                      <a:solidFill>
+                        <a:srgbClr val="D6DCE2"/>
+                      </a:solidFill>
+                    </a:lnR>
+                    <a:lnT w="6350">
+                      <a:solidFill>
+                        <a:srgbClr val="D6DCE2"/>
+                      </a:solidFill>
+                    </a:lnT>
+                    <a:lnB w="6350">
+                      <a:solidFill>
+                        <a:srgbClr val="D6DCE2"/>
+                      </a:solidFill>
+                    </a:lnB>
+                  </a:tcPr>
+                </a:tc>
+                <a:tc>
+                  <a:txBody>
+                    <a:bodyPr wrap="square"/>
+                    <a:lstStyle/>
+                    <a:p>
+                      <a:pPr algn="l">
+                        <a:spcBef>
+                          <a:spcPts val="0"/>
+                        </a:spcBef>
+                        <a:spcAft>
+                          <a:spcPts val="0"/>
+                        </a:spcAft>
+                        <a:lnSpc>
+                          <a:spcPct val="100000"/>
+                        </a:lnSpc>
+                      </a:pPr>
+                      <a:r>
+                        <a:rPr sz="1200" b="1">
+                          <a:solidFill>
+                            <a:srgbClr val="0E7A76"/>
+                          </a:solidFill>
+                          <a:latin typeface="Microsoft YaHei"/>
+                          <a:ea typeface="Microsoft YaHei"/>
+                          <a:cs typeface="Microsoft YaHei"/>
+                        </a:rPr>
+                        <a:t>2518</a:t>
+                      </a:r>
+                    </a:p>
+                  </a:txBody>
+                  <a:tcPr marL="73152" marR="73152" marT="36576" marB="27432" anchor="ctr">
+                    <a:solidFill>
+                      <a:srgbClr val="E7F3F2"/>
+                    </a:solidFill>
+                    <a:lnL w="6350">
+                      <a:solidFill>
+                        <a:srgbClr val="D6DCE2"/>
+                      </a:solidFill>
+                    </a:lnL>
+                    <a:lnR w="6350">
+                      <a:solidFill>
+                        <a:srgbClr val="D6DCE2"/>
+                      </a:solidFill>
+                    </a:lnR>
+                    <a:lnT w="6350">
+                      <a:solidFill>
+                        <a:srgbClr val="D6DCE2"/>
+                      </a:solidFill>
+                    </a:lnT>
+                    <a:lnB w="6350">
+                      <a:solidFill>
+                        <a:srgbClr val="D6DCE2"/>
+                      </a:solidFill>
+                    </a:lnB>
+                  </a:tcPr>
+                </a:tc>
+                <a:tc>
+                  <a:txBody>
+                    <a:bodyPr wrap="square"/>
+                    <a:lstStyle/>
+                    <a:p>
+                      <a:pPr algn="l">
+                        <a:spcBef>
+                          <a:spcPts val="0"/>
+                        </a:spcBef>
+                        <a:spcAft>
+                          <a:spcPts val="0"/>
+                        </a:spcAft>
+                        <a:lnSpc>
+                          <a:spcPct val="100000"/>
+                        </a:lnSpc>
+                      </a:pPr>
+                      <a:r>
+                        <a:rPr sz="1200" b="1">
+                          <a:solidFill>
+                            <a:srgbClr val="0E7A76"/>
+                          </a:solidFill>
+                          <a:latin typeface="Microsoft YaHei"/>
+                          <a:ea typeface="Microsoft YaHei"/>
+                          <a:cs typeface="Microsoft YaHei"/>
+                        </a:rPr>
+                        <a:t>19.7</a:t>
+                      </a:r>
+                    </a:p>
+                  </a:txBody>
+                  <a:tcPr marL="73152" marR="73152" marT="36576" marB="27432" anchor="ctr">
+                    <a:solidFill>
+                      <a:srgbClr val="E7F3F2"/>
+                    </a:solidFill>
+                    <a:lnL w="6350">
+                      <a:solidFill>
+                        <a:srgbClr val="D6DCE2"/>
+                      </a:solidFill>
+                    </a:lnL>
+                    <a:lnR w="6350">
+                      <a:solidFill>
+                        <a:srgbClr val="D6DCE2"/>
+                      </a:solidFill>
+                    </a:lnR>
+                    <a:lnT w="6350">
+                      <a:solidFill>
+                        <a:srgbClr val="D6DCE2"/>
+                      </a:solidFill>
+                    </a:lnT>
+                    <a:lnB w="6350">
+                      <a:solidFill>
+                        <a:srgbClr val="D6DCE2"/>
+                      </a:solidFill>
+                    </a:lnB>
+                  </a:tcPr>
+                </a:tc>
+                <a:tc>
+                  <a:txBody>
+                    <a:bodyPr wrap="square"/>
+                    <a:lstStyle/>
+                    <a:p>
+                      <a:pPr algn="l">
+                        <a:spcBef>
+                          <a:spcPts val="0"/>
+                        </a:spcBef>
+                        <a:spcAft>
+                          <a:spcPts val="0"/>
+                        </a:spcAft>
+                        <a:lnSpc>
+                          <a:spcPct val="100000"/>
+                        </a:lnSpc>
+                      </a:pPr>
+                      <a:r>
+                        <a:rPr sz="1200" b="1">
+                          <a:solidFill>
+                            <a:srgbClr val="0E7A76"/>
+                          </a:solidFill>
+                          <a:latin typeface="Microsoft YaHei"/>
+                          <a:ea typeface="Microsoft YaHei"/>
+                          <a:cs typeface="Microsoft YaHei"/>
+                        </a:rPr>
+                        <a:t>12% 经本卡 H2D</a:t>
+                      </a:r>
+                    </a:p>
+                  </a:txBody>
+                  <a:tcPr marL="73152" marR="73152" marT="36576" marB="27432" anchor="ctr">
+                    <a:solidFill>
+                      <a:srgbClr val="E7F3F2"/>
+                    </a:solidFill>
+                    <a:lnL w="6350">
+                      <a:solidFill>
+                        <a:srgbClr val="D6DCE2"/>
+                      </a:solidFill>
+                    </a:lnL>
+                    <a:lnR w="6350">
+                      <a:solidFill>
+                        <a:srgbClr val="D6DCE2"/>
+                      </a:solidFill>
+                    </a:lnR>
+                    <a:lnT w="6350">
+                      <a:solidFill>
+                        <a:srgbClr val="D6DCE2"/>
+                      </a:solidFill>
+                    </a:lnT>
+                    <a:lnB w="6350">
+                      <a:solidFill>
+                        <a:srgbClr val="D6DCE2"/>
+                      </a:solidFill>
+                    </a:lnB>
+                  </a:tcPr>
+                </a:tc>
+              </a:tr>
+              <a:tr h="475488">
+                <a:tc>
+                  <a:txBody>
+                    <a:bodyPr wrap="square"/>
+                    <a:lstStyle/>
+                    <a:p>
+                      <a:pPr algn="l">
+                        <a:spcBef>
+                          <a:spcPts val="0"/>
+                        </a:spcBef>
+                        <a:spcAft>
+                          <a:spcPts val="0"/>
+                        </a:spcAft>
+                        <a:lnSpc>
+                          <a:spcPct val="100000"/>
+                        </a:lnSpc>
+                      </a:pPr>
+                      <a:r>
+                        <a:rPr sz="1200" b="1">
+                          <a:solidFill>
+                            <a:srgbClr val="0E7A76"/>
+                          </a:solidFill>
+                          <a:latin typeface="Microsoft YaHei"/>
+                          <a:ea typeface="Microsoft YaHei"/>
+                          <a:cs typeface="Microsoft YaHei"/>
+                        </a:rPr>
+                        <a:t>1M</a:t>
+                      </a:r>
+                    </a:p>
+                  </a:txBody>
+                  <a:tcPr marL="73152" marR="73152" marT="36576" marB="27432" anchor="ctr">
+                    <a:solidFill>
+                      <a:srgbClr val="F4F7FA"/>
+                    </a:solidFill>
+                    <a:lnL w="6350">
+                      <a:solidFill>
+                        <a:srgbClr val="D6DCE2"/>
+                      </a:solidFill>
+                    </a:lnL>
+                    <a:lnR w="6350">
+                      <a:solidFill>
+                        <a:srgbClr val="D6DCE2"/>
+                      </a:solidFill>
+                    </a:lnR>
+                    <a:lnT w="6350">
+                      <a:solidFill>
+                        <a:srgbClr val="D6DCE2"/>
+                      </a:solidFill>
+                    </a:lnT>
+                    <a:lnB w="6350">
+                      <a:solidFill>
+                        <a:srgbClr val="D6DCE2"/>
+                      </a:solidFill>
+                    </a:lnB>
+                  </a:tcPr>
+                </a:tc>
+                <a:tc>
+                  <a:txBody>
+                    <a:bodyPr wrap="square"/>
+                    <a:lstStyle/>
+                    <a:p>
+                      <a:pPr algn="l">
+                        <a:spcBef>
+                          <a:spcPts val="0"/>
+                        </a:spcBef>
+                        <a:spcAft>
+                          <a:spcPts val="0"/>
+                        </a:spcAft>
+                        <a:lnSpc>
+                          <a:spcPct val="100000"/>
+                        </a:lnSpc>
+                      </a:pPr>
+                      <a:r>
+                        <a:rPr sz="1200" b="1">
+                          <a:solidFill>
+                            <a:srgbClr val="0E7A76"/>
+                          </a:solidFill>
+                          <a:latin typeface="Microsoft YaHei"/>
+                          <a:ea typeface="Microsoft YaHei"/>
+                          <a:cs typeface="Microsoft YaHei"/>
+                        </a:rPr>
+                        <a:t>5.18 GB</a:t>
+                      </a:r>
+                    </a:p>
+                  </a:txBody>
+                  <a:tcPr marL="73152" marR="73152" marT="36576" marB="27432" anchor="ctr">
+                    <a:solidFill>
+                      <a:srgbClr val="E7F3F2"/>
+                    </a:solidFill>
+                    <a:lnL w="6350">
+                      <a:solidFill>
+                        <a:srgbClr val="D6DCE2"/>
+                      </a:solidFill>
+                    </a:lnL>
+                    <a:lnR w="6350">
+                      <a:solidFill>
+                        <a:srgbClr val="D6DCE2"/>
+                      </a:solidFill>
+                    </a:lnR>
+                    <a:lnT w="6350">
+                      <a:solidFill>
+                        <a:srgbClr val="D6DCE2"/>
+                      </a:solidFill>
+                    </a:lnT>
+                    <a:lnB w="6350">
+                      <a:solidFill>
+                        <a:srgbClr val="D6DCE2"/>
+                      </a:solidFill>
+                    </a:lnB>
+                  </a:tcPr>
+                </a:tc>
+                <a:tc>
+                  <a:txBody>
+                    <a:bodyPr wrap="square"/>
+                    <a:lstStyle/>
+                    <a:p>
+                      <a:pPr algn="l">
+                        <a:spcBef>
+                          <a:spcPts val="0"/>
+                        </a:spcBef>
+                        <a:spcAft>
+                          <a:spcPts val="0"/>
+                        </a:spcAft>
+                        <a:lnSpc>
+                          <a:spcPct val="100000"/>
+                        </a:lnSpc>
+                      </a:pPr>
+                      <a:r>
+                        <a:rPr sz="1200" b="1">
+                          <a:solidFill>
+                            <a:srgbClr val="0E7A76"/>
+                          </a:solidFill>
+                          <a:latin typeface="Microsoft YaHei"/>
+                          <a:ea typeface="Microsoft YaHei"/>
+                          <a:cs typeface="Microsoft YaHei"/>
+                        </a:rPr>
+                        <a:t>1103</a:t>
+                      </a:r>
+                    </a:p>
+                  </a:txBody>
+                  <a:tcPr marL="73152" marR="73152" marT="36576" marB="27432" anchor="ctr">
+                    <a:solidFill>
+                      <a:srgbClr val="E7F3F2"/>
+                    </a:solidFill>
+                    <a:lnL w="6350">
+                      <a:solidFill>
+                        <a:srgbClr val="D6DCE2"/>
+                      </a:solidFill>
+                    </a:lnL>
+                    <a:lnR w="6350">
+                      <a:solidFill>
+                        <a:srgbClr val="D6DCE2"/>
+                      </a:solidFill>
+                    </a:lnR>
+                    <a:lnT w="6350">
+                      <a:solidFill>
+                        <a:srgbClr val="D6DCE2"/>
+                      </a:solidFill>
+                    </a:lnT>
+                    <a:lnB w="6350">
+                      <a:solidFill>
+                        <a:srgbClr val="D6DCE2"/>
+                      </a:solidFill>
+                    </a:lnB>
+                  </a:tcPr>
+                </a:tc>
+                <a:tc>
+                  <a:txBody>
+                    <a:bodyPr wrap="square"/>
+                    <a:lstStyle/>
+                    <a:p>
+                      <a:pPr algn="l">
+                        <a:spcBef>
+                          <a:spcPts val="0"/>
+                        </a:spcBef>
+                        <a:spcAft>
+                          <a:spcPts val="0"/>
+                        </a:spcAft>
+                        <a:lnSpc>
+                          <a:spcPct val="100000"/>
+                        </a:lnSpc>
+                      </a:pPr>
+                      <a:r>
+                        <a:rPr sz="1200" b="1">
+                          <a:solidFill>
+                            <a:srgbClr val="0E7A76"/>
+                          </a:solidFill>
+                          <a:latin typeface="Microsoft YaHei"/>
+                          <a:ea typeface="Microsoft YaHei"/>
+                          <a:cs typeface="Microsoft YaHei"/>
+                        </a:rPr>
+                        <a:t>213</a:t>
+                      </a:r>
+                    </a:p>
+                  </a:txBody>
+                  <a:tcPr marL="73152" marR="73152" marT="36576" marB="27432" anchor="ctr">
+                    <a:solidFill>
+                      <a:srgbClr val="E7F3F2"/>
+                    </a:solidFill>
+                    <a:lnL w="6350">
+                      <a:solidFill>
+                        <a:srgbClr val="D6DCE2"/>
+                      </a:solidFill>
+                    </a:lnL>
+                    <a:lnR w="6350">
+                      <a:solidFill>
+                        <a:srgbClr val="D6DCE2"/>
+                      </a:solidFill>
+                    </a:lnR>
+                    <a:lnT w="6350">
+                      <a:solidFill>
+                        <a:srgbClr val="D6DCE2"/>
+                      </a:solidFill>
+                    </a:lnT>
+                    <a:lnB w="6350">
+                      <a:solidFill>
+                        <a:srgbClr val="D6DCE2"/>
+                      </a:solidFill>
+                    </a:lnB>
+                  </a:tcPr>
+                </a:tc>
+                <a:tc>
+                  <a:txBody>
+                    <a:bodyPr wrap="square"/>
+                    <a:lstStyle/>
+                    <a:p>
+                      <a:pPr algn="l">
+                        <a:spcBef>
+                          <a:spcPts val="0"/>
+                        </a:spcBef>
+                        <a:spcAft>
+                          <a:spcPts val="0"/>
+                        </a:spcAft>
+                        <a:lnSpc>
+                          <a:spcPct val="100000"/>
+                        </a:lnSpc>
+                      </a:pPr>
+                      <a:r>
+                        <a:rPr sz="1200" b="1">
+                          <a:solidFill>
+                            <a:srgbClr val="0E7A76"/>
+                          </a:solidFill>
+                          <a:latin typeface="Microsoft YaHei"/>
+                          <a:ea typeface="Microsoft YaHei"/>
+                          <a:cs typeface="Microsoft YaHei"/>
+                        </a:rPr>
+                        <a:t>1.7</a:t>
+                      </a:r>
+                    </a:p>
+                  </a:txBody>
+                  <a:tcPr marL="73152" marR="73152" marT="36576" marB="27432" anchor="ctr">
+                    <a:solidFill>
+                      <a:srgbClr val="E7F3F2"/>
+                    </a:solidFill>
+                    <a:lnL w="6350">
+                      <a:solidFill>
+                        <a:srgbClr val="D6DCE2"/>
+                      </a:solidFill>
+                    </a:lnL>
+                    <a:lnR w="6350">
+                      <a:solidFill>
+                        <a:srgbClr val="D6DCE2"/>
+                      </a:solidFill>
+                    </a:lnR>
+                    <a:lnT w="6350">
+                      <a:solidFill>
+                        <a:srgbClr val="D6DCE2"/>
+                      </a:solidFill>
+                    </a:lnT>
+                    <a:lnB w="6350">
+                      <a:solidFill>
+                        <a:srgbClr val="D6DCE2"/>
+                      </a:solidFill>
+                    </a:lnB>
+                  </a:tcPr>
+                </a:tc>
+                <a:tc>
+                  <a:txBody>
+                    <a:bodyPr wrap="square"/>
+                    <a:lstStyle/>
+                    <a:p>
+                      <a:pPr algn="l">
+                        <a:spcBef>
+                          <a:spcPts val="0"/>
+                        </a:spcBef>
+                        <a:spcAft>
+                          <a:spcPts val="0"/>
+                        </a:spcAft>
+                        <a:lnSpc>
+                          <a:spcPct val="100000"/>
+                        </a:lnSpc>
+                      </a:pPr>
+                      <a:r>
+                        <a:rPr sz="1200" b="1">
+                          <a:solidFill>
+                            <a:srgbClr val="0E7A76"/>
+                          </a:solidFill>
+                          <a:latin typeface="Microsoft YaHei"/>
+                          <a:ea typeface="Microsoft YaHei"/>
+                          <a:cs typeface="Microsoft YaHei"/>
+                        </a:rPr>
+                        <a:t>1265</a:t>
+                      </a:r>
+                    </a:p>
+                  </a:txBody>
+                  <a:tcPr marL="73152" marR="73152" marT="36576" marB="27432" anchor="ctr">
+                    <a:solidFill>
+                      <a:srgbClr val="E7F3F2"/>
+                    </a:solidFill>
+                    <a:lnL w="6350">
+                      <a:solidFill>
+                        <a:srgbClr val="D6DCE2"/>
+                      </a:solidFill>
+                    </a:lnL>
+                    <a:lnR w="6350">
+                      <a:solidFill>
+                        <a:srgbClr val="D6DCE2"/>
+                      </a:solidFill>
+                    </a:lnR>
+                    <a:lnT w="6350">
+                      <a:solidFill>
+                        <a:srgbClr val="D6DCE2"/>
+                      </a:solidFill>
+                    </a:lnT>
+                    <a:lnB w="6350">
+                      <a:solidFill>
+                        <a:srgbClr val="D6DCE2"/>
+                      </a:solidFill>
+                    </a:lnB>
+                  </a:tcPr>
+                </a:tc>
+                <a:tc>
+                  <a:txBody>
+                    <a:bodyPr wrap="square"/>
+                    <a:lstStyle/>
+                    <a:p>
+                      <a:pPr algn="l">
+                        <a:spcBef>
+                          <a:spcPts val="0"/>
+                        </a:spcBef>
+                        <a:spcAft>
+                          <a:spcPts val="0"/>
+                        </a:spcAft>
+                        <a:lnSpc>
+                          <a:spcPct val="100000"/>
+                        </a:lnSpc>
+                      </a:pPr>
+                      <a:r>
+                        <a:rPr sz="1200" b="1">
+                          <a:solidFill>
+                            <a:srgbClr val="0E7A76"/>
+                          </a:solidFill>
+                          <a:latin typeface="Microsoft YaHei"/>
+                          <a:ea typeface="Microsoft YaHei"/>
+                          <a:cs typeface="Microsoft YaHei"/>
+                        </a:rPr>
+                        <a:t>9.9</a:t>
+                      </a:r>
+                    </a:p>
+                  </a:txBody>
+                  <a:tcPr marL="73152" marR="73152" marT="36576" marB="27432" anchor="ctr">
+                    <a:solidFill>
+                      <a:srgbClr val="E7F3F2"/>
+                    </a:solidFill>
+                    <a:lnL w="6350">
+                      <a:solidFill>
+                        <a:srgbClr val="D6DCE2"/>
+                      </a:solidFill>
+                    </a:lnL>
+                    <a:lnR w="6350">
+                      <a:solidFill>
+                        <a:srgbClr val="D6DCE2"/>
+                      </a:solidFill>
+                    </a:lnR>
+                    <a:lnT w="6350">
+                      <a:solidFill>
+                        <a:srgbClr val="D6DCE2"/>
+                      </a:solidFill>
+                    </a:lnT>
+                    <a:lnB w="6350">
+                      <a:solidFill>
+                        <a:srgbClr val="D6DCE2"/>
+                      </a:solidFill>
+                    </a:lnB>
+                  </a:tcPr>
+                </a:tc>
+                <a:tc>
+                  <a:txBody>
+                    <a:bodyPr wrap="square"/>
+                    <a:lstStyle/>
+                    <a:p>
+                      <a:pPr algn="l">
+                        <a:spcBef>
+                          <a:spcPts val="0"/>
+                        </a:spcBef>
+                        <a:spcAft>
+                          <a:spcPts val="0"/>
+                        </a:spcAft>
+                        <a:lnSpc>
+                          <a:spcPct val="100000"/>
+                        </a:lnSpc>
+                      </a:pPr>
+                      <a:r>
+                        <a:rPr sz="1200" b="1">
+                          <a:solidFill>
+                            <a:srgbClr val="0E7A76"/>
+                          </a:solidFill>
+                          <a:latin typeface="Microsoft YaHei"/>
+                          <a:ea typeface="Microsoft YaHei"/>
+                          <a:cs typeface="Microsoft YaHei"/>
+                        </a:rPr>
+                        <a:t>13% 经本卡 H2D</a:t>
+                      </a:r>
+                    </a:p>
+                  </a:txBody>
+                  <a:tcPr marL="73152" marR="73152" marT="36576" marB="27432" anchor="ctr">
+                    <a:solidFill>
+                      <a:srgbClr val="E7F3F2"/>
+                    </a:solidFill>
+                    <a:lnL w="6350">
+                      <a:solidFill>
+                        <a:srgbClr val="D6DCE2"/>
+                      </a:solidFill>
+                    </a:lnL>
+                    <a:lnR w="6350">
+                      <a:solidFill>
+                        <a:srgbClr val="D6DCE2"/>
+                      </a:solidFill>
+                    </a:lnR>
+                    <a:lnT w="6350">
+                      <a:solidFill>
+                        <a:srgbClr val="D6DCE2"/>
+                      </a:solidFill>
+                    </a:lnT>
+                    <a:lnB w="6350">
+                      <a:solidFill>
+                        <a:srgbClr val="D6DCE2"/>
+                      </a:solidFill>
+                    </a:lnB>
+                  </a:tcPr>
+                </a:tc>
+              </a:tr>
+            </a:tbl>
+          </a:graphicData>
+        </a:graphic>
+      </p:graphicFrame>
+      <p:sp>
+        <p:nvSpPr>
+          <p:cNvPr id="11" name="Rounded Rectangle 10"/>
+          <p:cNvSpPr/>
+          <p:nvPr/>
+        </p:nvSpPr>
+        <p:spPr>
+          <a:xfrm>
+            <a:off x="384048" y="5285232"/>
+            <a:ext cx="11430000" cy="1133856"/>
+          </a:xfrm>
+          <a:prstGeom prst="roundRect">
+            <a:avLst/>
+          </a:prstGeom>
+          <a:solidFill>
+            <a:srgbClr val="F8F1E4"/>
+          </a:solidFill>
+          <a:ln>
+            <a:noFill/>
+          </a:ln>
+        </p:spPr>
+        <p:style>
+          <a:lnRef idx="1">
+            <a:schemeClr val="accent1"/>
+          </a:lnRef>
+          <a:fillRef idx="3">
+            <a:schemeClr val="accent1"/>
+          </a:fillRef>
+          <a:effectRef idx="2">
+            <a:schemeClr val="accent1"/>
+          </a:effectRef>
+          <a:fontRef idx="minor">
+            <a:schemeClr val="lt1"/>
+          </a:fontRef>
+        </p:style>
+        <p:txBody>
+          <a:bodyPr rtlCol="0" anchor="ctr"/>
+          <a:lstStyle/>
+          <a:p>
+            <a:pPr algn="ctr"/>
+          </a:p>
+        </p:txBody>
+      </p:sp>
+      <p:sp>
+        <p:nvSpPr>
+          <p:cNvPr id="12" name="TextBox 11"/>
+          <p:cNvSpPr txBox="1"/>
+          <p:nvPr/>
+        </p:nvSpPr>
+        <p:spPr>
+          <a:xfrm>
+            <a:off x="530352" y="5358384"/>
+            <a:ext cx="11137392" cy="987552"/>
+          </a:xfrm>
+          <a:prstGeom prst="rect">
+            <a:avLst/>
+          </a:prstGeom>
+          <a:noFill/>
+        </p:spPr>
+        <p:txBody>
+          <a:bodyPr wrap="square" lIns="0" rIns="0" tIns="0" bIns="0" anchor="ctr"/>
+          <a:lstStyle/>
+          <a:p>
+            <a:pPr algn="l">
+              <a:spcBef>
+                <a:spcPts val="0"/>
+              </a:spcBef>
+              <a:spcAft>
+                <a:spcPts val="0"/>
+              </a:spcAft>
+            </a:pPr>
+            <a:r>
+              <a:rPr sz="1400" b="0">
+                <a:solidFill>
+                  <a:srgbClr val="7A541C"/>
+                </a:solidFill>
+                <a:latin typeface="Microsoft YaHei"/>
+                <a:ea typeface="Microsoft YaHei"/>
+                <a:cs typeface="Microsoft YaHei"/>
+              </a:rPr>
+              <a:t>10 毫秒到 1M 都在 HBM 里，时间卡在读专家权重，全局批从 231 降到 213。</a:t>
+            </a:r>
+          </a:p>
+          <a:p>
+            <a:pPr algn="l">
+              <a:spcBef>
+                <a:spcPts val="0"/>
+              </a:spcBef>
+              <a:spcAft>
+                <a:spcPts val="0"/>
+              </a:spcAft>
+            </a:pPr>
+            <a:r>
+              <a:rPr sz="1400" b="0">
+                <a:solidFill>
+                  <a:srgbClr val="7A541C"/>
+                </a:solidFill>
+                <a:latin typeface="Microsoft YaHei"/>
+                <a:ea typeface="Microsoft YaHei"/>
+                <a:cs typeface="Microsoft YaHei"/>
+              </a:rPr>
+              <a:t>30 毫秒在 128K 及更短仍是 6928，卡在机内 allreduce 16.6 毫秒加读权重 13.4 毫秒。约 1.66×10^5 token 以后，6928 条放不进 5.72 TB，溢出走 H2D。</a:t>
+            </a:r>
+          </a:p>
+          <a:p>
+            <a:pPr algn="l">
+              <a:spcBef>
+                <a:spcPts val="0"/>
+              </a:spcBef>
+              <a:spcAft>
+                <a:spcPts val="0"/>
+              </a:spcAft>
+            </a:pPr>
+            <a:r>
+              <a:rPr sz="1400" b="0">
+                <a:solidFill>
+                  <a:srgbClr val="7A541C"/>
+                </a:solidFill>
+                <a:latin typeface="Microsoft YaHei"/>
+                <a:ea typeface="Microsoft YaHei"/>
+                <a:cs typeface="Microsoft YaHei"/>
+              </a:rPr>
+              <a:t>Prefill 另按 90% KV 命中、参数面 40 GB/s 读 KV。1M 的 TTFT 是 0.35 秒，4K 到 1M 都在 10 秒以内。</a:t>
             </a:r>
           </a:p>
         </p:txBody>

</xml_diff>